<commit_message>
Baselines, ablation (fixed for shape-off config), runtime, candidate comparison (theta-LOCO, Sentinel+LOF union not adopted), partial nested aggregate; figures and slides rebuilt
</commit_message>
<xml_diff>
--- a/slides/Sentinel_Challenge2.pptx
+++ b/slides/Sentinel_Challenge2.pptx
@@ -226,10 +226,10 @@
                   <c:v>D3 shape only</c:v>
                 </c:pt>
                 <c:pt idx="3">
-                  <c:v>D1 + D2, no shape</c:v>
+                  <c:v>D1 + D2 + D3 (shape on)</c:v>
                 </c:pt>
                 <c:pt idx="4">
-                  <c:v>all three, no calibration</c:v>
+                  <c:v>D1 + D2, no calibration</c:v>
                 </c:pt>
                 <c:pt idx="5">
                   <c:v>+ calibration, plain threshold</c:v>
@@ -253,31 +253,31 @@
                 <c:formatCode>General</c:formatCode>
                 <c:ptCount val="9"/>
                 <c:pt idx="0">
-                  <c:v>0.395</c:v>
+                  <c:v>0.417</c:v>
                 </c:pt>
                 <c:pt idx="1">
-                  <c:v>0.506</c:v>
+                  <c:v>0.422</c:v>
                 </c:pt>
                 <c:pt idx="2">
-                  <c:v>0.183</c:v>
+                  <c:v>0.176</c:v>
                 </c:pt>
                 <c:pt idx="3">
-                  <c:v>0.536</c:v>
+                  <c:v>0.465</c:v>
                 </c:pt>
                 <c:pt idx="4">
-                  <c:v>0.404</c:v>
+                  <c:v>0.429</c:v>
                 </c:pt>
                 <c:pt idx="5">
-                  <c:v>0.535</c:v>
+                  <c:v>0.472</c:v>
                 </c:pt>
                 <c:pt idx="6">
-                  <c:v>0.52</c:v>
+                  <c:v>0.477</c:v>
                 </c:pt>
                 <c:pt idx="7">
-                  <c:v>0.522</c:v>
+                  <c:v>0.475</c:v>
                 </c:pt>
                 <c:pt idx="8">
-                  <c:v>0.532</c:v>
+                  <c:v>0.479</c:v>
                 </c:pt>
               </c:numCache>
             </c:numRef>
@@ -349,7 +349,7 @@
       <c:valAx>
         <c:axId val="-2113994440"/>
         <c:scaling>
-          <c:max val="0.6704980842911877"/>
+          <c:max val="0.599078341013825"/>
           <c:min val="0.0"/>
         </c:scaling>
         <c:delete/>
@@ -461,22 +461,22 @@
               <c:strCache>
                 <c:ptCount val="6"/>
                 <c:pt idx="0">
-                  <c:v>Ad exchange (9/14)</c:v>
+                  <c:v>Artificial (4/6)</c:v>
                 </c:pt>
                 <c:pt idx="1">
-                  <c:v>Tweets (22/33)</c:v>
+                  <c:v>Tweets (21/33)</c:v>
                 </c:pt>
                 <c:pt idx="2">
-                  <c:v>Traffic (6/14)</c:v>
+                  <c:v>AWS (13/30)</c:v>
                 </c:pt>
                 <c:pt idx="3">
-                  <c:v>Artificial (4/6)</c:v>
+                  <c:v>Ad exchange (4/14)</c:v>
                 </c:pt>
                 <c:pt idx="4">
-                  <c:v>AWS (17/30)</c:v>
+                  <c:v>Known cause (7/19)</c:v>
                 </c:pt>
                 <c:pt idx="5">
-                  <c:v>Known cause (8/19)</c:v>
+                  <c:v>Traffic (3/14)</c:v>
                 </c:pt>
               </c:strCache>
             </c:strRef>
@@ -488,22 +488,22 @@
                 <c:formatCode>General</c:formatCode>
                 <c:ptCount val="6"/>
                 <c:pt idx="0">
-                  <c:v>0.713</c:v>
+                  <c:v>0.8</c:v>
                 </c:pt>
                 <c:pt idx="1">
-                  <c:v>0.553</c:v>
+                  <c:v>0.545</c:v>
                 </c:pt>
                 <c:pt idx="2">
-                  <c:v>0.536</c:v>
+                  <c:v>0.5</c:v>
                 </c:pt>
                 <c:pt idx="3">
-                  <c:v>0.533</c:v>
+                  <c:v>0.4</c:v>
                 </c:pt>
                 <c:pt idx="4">
-                  <c:v>0.514</c:v>
+                  <c:v>0.368</c:v>
                 </c:pt>
                 <c:pt idx="5">
-                  <c:v>0.444</c:v>
+                  <c:v>0.316</c:v>
                 </c:pt>
               </c:numCache>
             </c:numRef>
@@ -1005,7 +1005,7 @@
           <a:lstStyle/>
           <a:p>
             <a:r>
-              <a:t>Sentinel reads a series one point at a time. For every point it gives a score, a label and, for every alert, the reason. Three simple detectors, one calibrated scale, one state machine.</a:t>
+              <a:t>Sentinel reads a series one point at a time. For every point it gives a score, a label and, for every alert, the reason. Simple causal detectors, one calibrated scale, one state machine.</a:t>
             </a:r>
           </a:p>
         </p:txBody>
@@ -1145,7 +1145,7 @@
           <a:lstStyle/>
           <a:p>
             <a:r>
-              <a:t>Precision per event is what an operator feels. The judging metric is event F1, so the design goal is: catch the incident once, early enough, and do not alert on its aftermath.</a:t>
+              <a:t>Precision per alert is what an operator feels. The judging metric is event F1, so the design goal is: trigger once, inside the incident, early, and stay quiet on its aftermath.</a:t>
             </a:r>
           </a:p>
         </p:txBody>
@@ -1425,7 +1425,7 @@
           <a:lstStyle/>
           <a:p>
             <a:r>
-              <a:t>Each stage keeps the best of the previous one. The all-files F1 is optimistic; the LOCO-CV number is what a new category would see. The ablation shows what each part of the design adds.</a:t>
+              <a:t>Each stage keeps the best of the previous one. The all-files F1 is optimistic; the nested LOCO number re-runs the whole search without the held-out category and is what a new category would see.</a:t>
             </a:r>
           </a:p>
         </p:txBody>
@@ -1495,7 +1495,7 @@
           <a:lstStyle/>
           <a:p>
             <a:r>
-              <a:t>We never use point adjustment, which inflates scores. A long alert that covers a window counts once; an alert far from any window is a false alert, however short.</a:t>
+              <a:t>No point adjustment. An alert is judged where it starts: one that starts before the window and runs into it is a false alert and the window counts as missed, exactly as NAB scores it.</a:t>
             </a:r>
           </a:p>
         </p:txBody>
@@ -4843,7 +4843,7 @@
                 </a:solidFill>
                 <a:latin typeface="Calibri"/>
               </a:rPr>
-              <a:t>machine_temperature_system_failure (NAB) · orange = labelled anomaly window · red = Sentinel alert</a:t>
+              <a:t>machine_temperature_system_failure (NAB) · orange = labelled anomaly window · red line = Sentinel alert trigger · light red = open event</a:t>
             </a:r>
           </a:p>
         </p:txBody>
@@ -5368,7 +5368,7 @@
                 </a:solidFill>
                 <a:latin typeface="Calibri"/>
               </a:rPr>
-              <a:t>Three simple, causal detectors + calibration + event logic: event F1 0.53 on NAB (0.49 on held-out categories).</a:t>
+              <a:t>Two causal detectors (residual + CUSUM) + calibration + event logic: trigger-based event F1 0.48 on NAB, all files; 0.38 held-out (nested LOCO, partial: 3 of 7 categories).</a:t>
             </a:r>
           </a:p>
           <a:p>
@@ -5384,7 +5384,7 @@
                 </a:solidFill>
                 <a:latin typeface="Calibri"/>
               </a:rPr>
-              <a:t>One alert per incident, each with a reason; tens of microseconds per point on a laptop.</a:t>
+              <a:t>One alert per incident, each with a reason; tens of microseconds per point.</a:t>
             </a:r>
           </a:p>
           <a:p>
@@ -5400,7 +5400,7 @@
                 </a:solidFill>
                 <a:latin typeface="Calibri"/>
               </a:rPr>
-              <a:t>Every number is reproducible from one command per step.</a:t>
+              <a:t>Metric audited; every number reproducible from one command per step.</a:t>
             </a:r>
           </a:p>
         </p:txBody>
@@ -6183,7 +6183,7 @@
                 </a:solidFill>
                 <a:latin typeface="Calibri"/>
               </a:rPr>
-              <a:t>2 alerts</a:t>
+              <a:t>1 alert</a:t>
             </a:r>
           </a:p>
         </p:txBody>
@@ -6218,7 +6218,7 @@
                 </a:solidFill>
                 <a:latin typeface="Calibri"/>
               </a:rPr>
-              <a:t>Sentinel, 2 inside the window</a:t>
+              <a:t>Sentinel, 1 triggered inside the window</a:t>
             </a:r>
           </a:p>
         </p:txBody>
@@ -6980,7 +6980,7 @@
                           </a:solidFill>
                           <a:latin typeface="Calibri"/>
                         </a:rPr>
-                        <a:t>2</a:t>
+                        <a:t>6</a:t>
                       </a:r>
                     </a:p>
                   </a:txBody>
@@ -7214,7 +7214,7 @@
                           </a:solidFill>
                           <a:latin typeface="Calibri"/>
                         </a:rPr>
-                        <a:t>0</a:t>
+                        <a:t>1</a:t>
                       </a:r>
                     </a:p>
                   </a:txBody>
@@ -7331,7 +7331,7 @@
                           </a:solidFill>
                           <a:latin typeface="Calibri"/>
                         </a:rPr>
-                        <a:t>0</a:t>
+                        <a:t>1</a:t>
                       </a:r>
                     </a:p>
                   </a:txBody>
@@ -7448,7 +7448,7 @@
                           </a:solidFill>
                           <a:latin typeface="Calibri"/>
                         </a:rPr>
-                        <a:t>15</a:t>
+                        <a:t>21</a:t>
                       </a:r>
                     </a:p>
                   </a:txBody>
@@ -7748,7 +7748,7 @@
         <p:spPr>
           <a:xfrm>
             <a:off x="6400800" y="1554480"/>
-            <a:ext cx="4850837" cy="4800600"/>
+            <a:ext cx="4841972" cy="4800600"/>
           </a:xfrm>
           <a:prstGeom prst="rect">
             <a:avLst/>
@@ -8245,7 +8245,7 @@
                 </a:solidFill>
                 <a:latin typeface="Calibri"/>
               </a:rPr>
-              <a:t>odd patterns</a:t>
+              <a:t>odd patterns (off in final.yaml)</a:t>
             </a:r>
           </a:p>
         </p:txBody>
@@ -8380,7 +8380,7 @@
                 </a:solidFill>
                 <a:latin typeface="Calibri"/>
               </a:rPr>
-              <a:t>U = max U_k − log10 3
+              <a:t>U = max U_k − log10 K
 Ū = smoothed U</a:t>
             </a:r>
           </a:p>
@@ -8906,7 +8906,7 @@
                 </a:solidFill>
                 <a:latin typeface="Calibri"/>
               </a:rPr>
-              <a:t>44 µs</a:t>
+              <a:t>23 µs</a:t>
             </a:r>
           </a:p>
         </p:txBody>
@@ -8941,7 +8941,7 @@
                 </a:solidFill>
                 <a:latin typeface="Calibri"/>
               </a:rPr>
-              <a:t>mean time per point on a laptop CPU (p99 243 µs)</a:t>
+              <a:t>mean time per point, one CPU core (p99 183 µs)</a:t>
             </a:r>
           </a:p>
         </p:txBody>
@@ -9134,7 +9134,7 @@
                 </a:solidFill>
                 <a:latin typeface="Calibri"/>
               </a:rPr>
-              <a:t>Three cheap detectors, one calibrated scale, one state machine</a:t>
+              <a:t>Cheap detectors, one calibrated scale, one state machine</a:t>
             </a:r>
           </a:p>
         </p:txBody>
@@ -9554,7 +9554,7 @@
                 </a:solidFill>
                 <a:latin typeface="Calibri"/>
               </a:rPr>
-              <a:t>Unusual patterns at normal amplitude</a:t>
+              <a:t>Unusual patterns (optional; off in final.yaml)</a:t>
             </a:r>
           </a:p>
         </p:txBody>
@@ -9590,7 +9590,7 @@
                 <a:latin typeface="Calibri"/>
               </a:rPr>
               <a:t>distance of newest z-normalized 16-point window
-to its nearest of the last 2000 windows</a:t>
+to its nearest of the last 1000 windows</a:t>
             </a:r>
           </a:p>
         </p:txBody>
@@ -9868,7 +9868,7 @@
                 </a:solidFill>
                 <a:latin typeface="Calibri"/>
               </a:rPr>
-              <a:t>ANOMALOUS</a:t>
+              <a:t>EVENT</a:t>
             </a:r>
           </a:p>
         </p:txBody>
@@ -10067,7 +10067,7 @@
                 <a:latin typeface="Calibri"/>
               </a:rPr>
               <a:t>Ū &lt; 3.0 or
-length ≥ 800</a:t>
+length ≥ 200</a:t>
             </a:r>
           </a:p>
         </p:txBody>
@@ -10208,7 +10208,7 @@
                 </a:solidFill>
                 <a:latin typeface="Calibri"/>
               </a:rPr>
-              <a:t>after 100 quiet points</a:t>
+              <a:t>after 400 quiet points</a:t>
             </a:r>
           </a:p>
         </p:txBody>
@@ -10256,7 +10256,7 @@
                 </a:solidFill>
                 <a:latin typeface="Calibri"/>
               </a:rPr>
-              <a:t>U = max_k U_k − log10 3 (Bonferroni); Ū = mean over 5 points</a:t>
+              <a:t>U = max_k U_k − log10 K (Bonferroni, K = 2 detectors on); Ū = mean over 5 points</a:t>
             </a:r>
           </a:p>
           <a:p>
@@ -10272,7 +10272,32 @@
                 </a:solidFill>
                 <a:latin typeface="Calibri"/>
               </a:rPr>
-              <a:t>While ANOMALOUS: </a:t>
+              <a:t>Label: </a:t>
+            </a:r>
+            <a:r>
+              <a:rPr sz="1200" b="0" i="0">
+                <a:solidFill>
+                  <a:srgbClr val="52514E"/>
+                </a:solidFill>
+                <a:latin typeface="Calibri"/>
+              </a:rPr>
+              <a:t>ANOMALOUS on the first 1 row(s) of an event (the trigger); the span is in state/event_id and events.jsonl.</a:t>
+            </a:r>
+          </a:p>
+          <a:p>
+            <a:pPr algn="l">
+              <a:spcAft>
+                <a:spcPts val="400"/>
+              </a:spcAft>
+            </a:pPr>
+            <a:r>
+              <a:rPr sz="1200" b="1" i="0">
+                <a:solidFill>
+                  <a:srgbClr val="52514E"/>
+                </a:solidFill>
+                <a:latin typeface="Calibri"/>
+              </a:rPr>
+              <a:t>While EVENT: </a:t>
             </a:r>
             <a:r>
               <a:rPr sz="1200" b="0" i="0">
@@ -10439,7 +10464,7 @@
                 </a:solidFill>
                 <a:latin typeface="Calibri"/>
               </a:rPr>
-              <a:t>218 configs evaluated exactly on all 58 files; every run in experiments/runs.csv</a:t>
+              <a:t>objective: trigger-based event F1; 231 configs in the final search, each run on all 58 files; every run in experiments/runs.csv</a:t>
             </a:r>
           </a:p>
         </p:txBody>
@@ -10461,7 +10486,7 @@
         <p:spPr>
           <a:xfrm>
             <a:off x="548640" y="1508760"/>
-            <a:ext cx="5760720" cy="2846795"/>
+            <a:ext cx="5760720" cy="2804625"/>
           </a:xfrm>
           <a:prstGeom prst="rect">
             <a:avLst/>
@@ -10516,7 +10541,7 @@
                 </a:solidFill>
                 <a:latin typeface="Calibri"/>
               </a:rPr>
-              <a:t>Ablation: event F1, each variant with its own best θ_enter</a:t>
+              <a:t>Ablation: trigger-based event F1 (ET), each variant with its own best θ_enter</a:t>
             </a:r>
           </a:p>
         </p:txBody>
@@ -10564,7 +10589,7 @@
                 </a:solidFill>
                 <a:latin typeface="Calibri"/>
               </a:rPr>
-              <a:t>detector params (108): F1 0.475</a:t>
+              <a:t>detector params (108): ET F1 0.419</a:t>
             </a:r>
           </a:p>
           <a:p>
@@ -10589,7 +10614,7 @@
                 </a:solidFill>
                 <a:latin typeface="Calibri"/>
               </a:rPr>
-              <a:t>θ, hysteresis, smoothing (36): F1 0.505</a:t>
+              <a:t>θ, hysteresis, smoothing (36): ET F1 0.452</a:t>
             </a:r>
           </a:p>
           <a:p>
@@ -10614,7 +10639,7 @@
                 </a:solidFill>
                 <a:latin typeface="Calibri"/>
               </a:rPr>
-              <a:t>cooldown, max length (27): F1 0.536</a:t>
+              <a:t>cooldown, max length (36): ET F1 0.464</a:t>
             </a:r>
           </a:p>
           <a:p>
@@ -10639,7 +10664,7 @@
                 </a:solidFill>
                 <a:latin typeface="Calibri"/>
               </a:rPr>
-              <a:t>Fisher, peak-or-mean, learn in cooldown (24): no gain, kept</a:t>
+              <a:t>Fisher, peak-or-mean, learn in cooldown (24): ET F1 0.470</a:t>
             </a:r>
           </a:p>
           <a:p>
@@ -10714,7 +10739,7 @@
                 </a:solidFill>
                 <a:latin typeface="Calibri"/>
               </a:rPr>
-              <a:t>shape detector off (6): no gain, kept</a:t>
+              <a:t>shape detector off (6): ET F1 0.488</a:t>
             </a:r>
           </a:p>
           <a:p>
@@ -10764,7 +10789,7 @@
                 </a:solidFill>
                 <a:latin typeface="Calibri"/>
               </a:rPr>
-              <a:t>F1 0.532 (stability rule); LOCO-CV over all 218 configs 0.486</a:t>
+              <a:t>ET F1 0.479 (stability rule); ET F1, held-out (nested LOCO, partial: 3 of 7 categories): 0.381</a:t>
             </a:r>
           </a:p>
         </p:txBody>
@@ -10887,7 +10912,7 @@
                 </a:solidFill>
                 <a:latin typeface="Calibri"/>
               </a:rPr>
-              <a:t>Event F1 on held-out categories, no point adjustment</a:t>
+              <a:t>Event F1 counted at the alert trigger, on held-out categories</a:t>
             </a:r>
           </a:p>
         </p:txBody>
@@ -10922,7 +10947,7 @@
                 </a:solidFill>
                 <a:latin typeface="Calibri"/>
               </a:rPr>
-              <a:t>Precision counts alerts, recall counts labelled windows; both summed over files</a:t>
+              <a:t>No official evaluator was given, so we defined the metric and audited it against degenerate strategies</a:t>
             </a:r>
           </a:p>
         </p:txBody>
@@ -10935,7 +10960,7 @@
         </p:nvSpPr>
         <p:spPr>
           <a:xfrm>
-            <a:off x="548640" y="2148840"/>
+            <a:off x="548640" y="2011680"/>
             <a:ext cx="5212080" cy="54864"/>
           </a:xfrm>
           <a:prstGeom prst="rect">
@@ -10979,7 +11004,7 @@
         </p:nvSpPr>
         <p:spPr>
           <a:xfrm>
-            <a:off x="1097280" y="1645920"/>
+            <a:off x="1097280" y="1508760"/>
             <a:ext cx="1463040" cy="457200"/>
           </a:xfrm>
           <a:prstGeom prst="rect">
@@ -11023,7 +11048,7 @@
         </p:nvSpPr>
         <p:spPr>
           <a:xfrm>
-            <a:off x="3840480" y="1645920"/>
+            <a:off x="3840480" y="1508760"/>
             <a:ext cx="1280160" cy="457200"/>
           </a:xfrm>
           <a:prstGeom prst="rect">
@@ -11067,8 +11092,8 @@
         </p:nvSpPr>
         <p:spPr>
           <a:xfrm>
-            <a:off x="1554480" y="2286000"/>
-            <a:ext cx="640080" cy="274320"/>
+            <a:off x="1554480" y="2121408"/>
+            <a:ext cx="45720" cy="365760"/>
           </a:xfrm>
           <a:prstGeom prst="rect">
             <a:avLst/>
@@ -11111,8 +11136,8 @@
         </p:nvSpPr>
         <p:spPr>
           <a:xfrm>
-            <a:off x="2926080" y="2286000"/>
-            <a:ext cx="365760" cy="274320"/>
+            <a:off x="3063240" y="2121408"/>
+            <a:ext cx="45720" cy="365760"/>
           </a:xfrm>
           <a:prstGeom prst="rect">
             <a:avLst/>
@@ -11149,14 +11174,58 @@
       </p:sp>
       <p:sp>
         <p:nvSpPr>
-          <p:cNvPr id="9" name="TextBox 8"/>
+          <p:cNvPr id="9" name="Rectangle 8"/>
+          <p:cNvSpPr/>
+          <p:nvPr/>
+        </p:nvSpPr>
+        <p:spPr>
+          <a:xfrm>
+            <a:off x="868680" y="2121408"/>
+            <a:ext cx="45720" cy="365760"/>
+          </a:xfrm>
+          <a:prstGeom prst="rect">
+            <a:avLst/>
+          </a:prstGeom>
+          <a:solidFill>
+            <a:srgbClr val="E34948"/>
+          </a:solidFill>
+          <a:ln>
+            <a:noFill/>
+          </a:ln>
+          <a:effectLst/>
+        </p:spPr>
+        <p:style>
+          <a:lnRef idx="1">
+            <a:schemeClr val="accent1"/>
+          </a:lnRef>
+          <a:fillRef idx="3">
+            <a:schemeClr val="accent1"/>
+          </a:fillRef>
+          <a:effectRef idx="2">
+            <a:schemeClr val="accent1"/>
+          </a:effectRef>
+          <a:fontRef idx="minor">
+            <a:schemeClr val="lt1"/>
+          </a:fontRef>
+        </p:style>
+        <p:txBody>
+          <a:bodyPr rtlCol="0" anchor="ctr"/>
+          <a:lstStyle/>
+          <a:p>
+            <a:pPr algn="ctr"/>
+          </a:p>
+        </p:txBody>
+      </p:sp>
+      <p:sp>
+        <p:nvSpPr>
+          <p:cNvPr id="10" name="TextBox 9"/>
           <p:cNvSpPr txBox="1"/>
           <p:nvPr/>
         </p:nvSpPr>
         <p:spPr>
           <a:xfrm>
-            <a:off x="1097280" y="2606040"/>
-            <a:ext cx="1645920" cy="365760"/>
+            <a:off x="1417319" y="2468880"/>
+            <a:ext cx="1188720" cy="365760"/>
           </a:xfrm>
           <a:prstGeom prst="rect">
             <a:avLst/>
@@ -11177,20 +11246,20 @@
                 </a:solidFill>
                 <a:latin typeface="Calibri"/>
               </a:rPr>
-              <a:t>hit: TP</a:t>
-            </a:r>
-          </a:p>
-        </p:txBody>
-      </p:sp>
-      <p:sp>
-        <p:nvSpPr>
-          <p:cNvPr id="10" name="TextBox 9"/>
+              <a:t>true alert</a:t>
+            </a:r>
+          </a:p>
+        </p:txBody>
+      </p:sp>
+      <p:sp>
+        <p:nvSpPr>
+          <p:cNvPr id="11" name="TextBox 10"/>
           <p:cNvSpPr txBox="1"/>
           <p:nvPr/>
         </p:nvSpPr>
         <p:spPr>
           <a:xfrm>
-            <a:off x="2788920" y="2606040"/>
+            <a:off x="2788920" y="2468880"/>
             <a:ext cx="1097280" cy="365760"/>
           </a:xfrm>
           <a:prstGeom prst="rect">
@@ -11219,14 +11288,14 @@
       </p:sp>
       <p:sp>
         <p:nvSpPr>
-          <p:cNvPr id="11" name="TextBox 10"/>
+          <p:cNvPr id="12" name="TextBox 11"/>
           <p:cNvSpPr txBox="1"/>
           <p:nvPr/>
         </p:nvSpPr>
         <p:spPr>
           <a:xfrm>
-            <a:off x="3840480" y="2606040"/>
-            <a:ext cx="1463040" cy="365760"/>
+            <a:off x="502919" y="2468880"/>
+            <a:ext cx="914400" cy="365760"/>
           </a:xfrm>
           <a:prstGeom prst="rect">
             <a:avLst/>
@@ -11247,6 +11316,41 @@
                 </a:solidFill>
                 <a:latin typeface="Calibri"/>
               </a:rPr>
+              <a:t>false</a:t>
+            </a:r>
+          </a:p>
+        </p:txBody>
+      </p:sp>
+      <p:sp>
+        <p:nvSpPr>
+          <p:cNvPr id="13" name="TextBox 12"/>
+          <p:cNvSpPr txBox="1"/>
+          <p:nvPr/>
+        </p:nvSpPr>
+        <p:spPr>
+          <a:xfrm>
+            <a:off x="3840480" y="2468880"/>
+            <a:ext cx="1463040" cy="365760"/>
+          </a:xfrm>
+          <a:prstGeom prst="rect">
+            <a:avLst/>
+          </a:prstGeom>
+          <a:noFill/>
+        </p:spPr>
+        <p:txBody>
+          <a:bodyPr wrap="square" anchor="t" lIns="0" rIns="0" tIns="0" bIns="0">
+            <a:spAutoFit/>
+          </a:bodyPr>
+          <a:lstStyle/>
+          <a:p>
+            <a:pPr algn="l"/>
+            <a:r>
+              <a:rPr sz="1100" b="0" i="0">
+                <a:solidFill>
+                  <a:srgbClr val="52514E"/>
+                </a:solidFill>
+                <a:latin typeface="Calibri"/>
+              </a:rPr>
               <a:t>missed window</a:t>
             </a:r>
           </a:p>
@@ -11254,14 +11358,14 @@
       </p:sp>
       <p:sp>
         <p:nvSpPr>
-          <p:cNvPr id="12" name="TextBox 11"/>
+          <p:cNvPr id="14" name="TextBox 13"/>
           <p:cNvSpPr txBox="1"/>
           <p:nvPr/>
         </p:nvSpPr>
         <p:spPr>
           <a:xfrm>
-            <a:off x="548640" y="3017520"/>
-            <a:ext cx="5212080" cy="1097280"/>
+            <a:off x="548640" y="2834640"/>
+            <a:ext cx="5212080" cy="1280160"/>
           </a:xfrm>
           <a:prstGeom prst="rect">
             <a:avLst/>
@@ -11295,7 +11399,7 @@
                 </a:solidFill>
                 <a:latin typeface="Calibri"/>
               </a:rPr>
-              <a:t> = alerts touching a window / alerts</a:t>
+              <a:t> = alerts triggered inside a window / alerts</a:t>
             </a:r>
           </a:p>
           <a:p>
@@ -11320,7 +11424,7 @@
                 </a:solidFill>
                 <a:latin typeface="Calibri"/>
               </a:rPr>
-              <a:t> = windows touched by an alert / windows</a:t>
+              <a:t> = windows with ≥ 1 alert trigger / windows</a:t>
             </a:r>
           </a:p>
           <a:p>
@@ -11345,21 +11449,21 @@
                 </a:solidFill>
                 <a:latin typeface="Calibri"/>
               </a:rPr>
-              <a:t> = first alert inside the window − window start</a:t>
-            </a:r>
-          </a:p>
-        </p:txBody>
-      </p:sp>
-      <p:sp>
-        <p:nvSpPr>
-          <p:cNvPr id="13" name="TextBox 12"/>
+              <a:t> = first trigger in the window − window start</a:t>
+            </a:r>
+          </a:p>
+        </p:txBody>
+      </p:sp>
+      <p:sp>
+        <p:nvSpPr>
+          <p:cNvPr id="15" name="TextBox 14"/>
           <p:cNvSpPr txBox="1"/>
           <p:nvPr/>
         </p:nvSpPr>
         <p:spPr>
           <a:xfrm>
-            <a:off x="548640" y="4114800"/>
-            <a:ext cx="5212080" cy="365760"/>
+            <a:off x="548640" y="3840480"/>
+            <a:ext cx="5212080" cy="914400"/>
           </a:xfrm>
           <a:prstGeom prst="rect">
             <a:avLst/>
@@ -11374,27 +11478,71 @@
           <a:p>
             <a:pPr algn="l"/>
             <a:r>
+              <a:rPr sz="1200" b="1" i="0">
+                <a:solidFill>
+                  <a:srgbClr val="52514E"/>
+                </a:solidFill>
+                <a:latin typeface="Calibri"/>
+              </a:rPr>
+              <a:t>Why not overlap F1? </a:t>
+            </a:r>
+            <a:r>
+              <a:rPr sz="1200" b="0" i="0">
+                <a:solidFill>
+                  <a:srgbClr val="52514E"/>
+                </a:solidFill>
+                <a:latin typeface="Calibri"/>
+              </a:rPr>
+              <a:t>flagging every row scores 0.95 under an overlap event F1, 0.00 under ours; random 1% of rows: 0.06. Details: reports/metric_audit.md.</a:t>
+            </a:r>
+          </a:p>
+        </p:txBody>
+      </p:sp>
+      <p:sp>
+        <p:nvSpPr>
+          <p:cNvPr id="16" name="TextBox 15"/>
+          <p:cNvSpPr txBox="1"/>
+          <p:nvPr/>
+        </p:nvSpPr>
+        <p:spPr>
+          <a:xfrm>
+            <a:off x="548640" y="4709160"/>
+            <a:ext cx="5212080" cy="365760"/>
+          </a:xfrm>
+          <a:prstGeom prst="rect">
+            <a:avLst/>
+          </a:prstGeom>
+          <a:noFill/>
+        </p:spPr>
+        <p:txBody>
+          <a:bodyPr wrap="square" anchor="t" lIns="0" rIns="0" tIns="0" bIns="0">
+            <a:spAutoFit/>
+          </a:bodyPr>
+          <a:lstStyle/>
+          <a:p>
+            <a:pPr algn="l"/>
+            <a:r>
               <a:rPr sz="1600" b="1" i="0">
                 <a:solidFill>
                   <a:srgbClr val="0B0B0B"/>
                 </a:solidFill>
                 <a:latin typeface="Calibri"/>
               </a:rPr>
-              <a:t>Leave-one-category-out (LOCO)</a:t>
-            </a:r>
-          </a:p>
-        </p:txBody>
-      </p:sp>
-      <p:sp>
-        <p:nvSpPr>
-          <p:cNvPr id="14" name="Rounded Rectangle 13"/>
+              <a:t>Nested leave-one-category-out (LOCO)</a:t>
+            </a:r>
+          </a:p>
+        </p:txBody>
+      </p:sp>
+      <p:sp>
+        <p:nvSpPr>
+          <p:cNvPr id="17" name="Rounded Rectangle 16"/>
           <p:cNvSpPr/>
           <p:nvPr/>
         </p:nvSpPr>
         <p:spPr>
           <a:xfrm>
-            <a:off x="548640" y="4526280"/>
-            <a:ext cx="685800" cy="502920"/>
+            <a:off x="548640" y="5120640"/>
+            <a:ext cx="685800" cy="457200"/>
           </a:xfrm>
           <a:prstGeom prst="roundRect">
             <a:avLst>
@@ -11442,14 +11590,14 @@
       </p:sp>
       <p:sp>
         <p:nvSpPr>
-          <p:cNvPr id="15" name="Rounded Rectangle 14"/>
+          <p:cNvPr id="18" name="Rounded Rectangle 17"/>
           <p:cNvSpPr/>
           <p:nvPr/>
         </p:nvSpPr>
         <p:spPr>
           <a:xfrm>
-            <a:off x="1289304" y="4526280"/>
-            <a:ext cx="685800" cy="502920"/>
+            <a:off x="1289304" y="5120640"/>
+            <a:ext cx="685800" cy="457200"/>
           </a:xfrm>
           <a:prstGeom prst="roundRect">
             <a:avLst>
@@ -11497,14 +11645,14 @@
       </p:sp>
       <p:sp>
         <p:nvSpPr>
-          <p:cNvPr id="16" name="Rounded Rectangle 15"/>
+          <p:cNvPr id="19" name="Rounded Rectangle 18"/>
           <p:cNvSpPr/>
           <p:nvPr/>
         </p:nvSpPr>
         <p:spPr>
           <a:xfrm>
-            <a:off x="2029968" y="4526280"/>
-            <a:ext cx="685800" cy="502920"/>
+            <a:off x="2029968" y="5120640"/>
+            <a:ext cx="685800" cy="457200"/>
           </a:xfrm>
           <a:prstGeom prst="roundRect">
             <a:avLst>
@@ -11552,14 +11700,14 @@
       </p:sp>
       <p:sp>
         <p:nvSpPr>
-          <p:cNvPr id="17" name="Rounded Rectangle 16"/>
+          <p:cNvPr id="20" name="Rounded Rectangle 19"/>
           <p:cNvSpPr/>
           <p:nvPr/>
         </p:nvSpPr>
         <p:spPr>
           <a:xfrm>
-            <a:off x="2770632" y="4526280"/>
-            <a:ext cx="685800" cy="502920"/>
+            <a:off x="2770632" y="5120640"/>
+            <a:ext cx="685800" cy="457200"/>
           </a:xfrm>
           <a:prstGeom prst="roundRect">
             <a:avLst>
@@ -11607,14 +11755,14 @@
       </p:sp>
       <p:sp>
         <p:nvSpPr>
-          <p:cNvPr id="18" name="Rounded Rectangle 17"/>
+          <p:cNvPr id="21" name="Rounded Rectangle 20"/>
           <p:cNvSpPr/>
           <p:nvPr/>
         </p:nvSpPr>
         <p:spPr>
           <a:xfrm>
-            <a:off x="3511296" y="4526280"/>
-            <a:ext cx="685800" cy="502920"/>
+            <a:off x="3511296" y="5120640"/>
+            <a:ext cx="685800" cy="457200"/>
           </a:xfrm>
           <a:prstGeom prst="roundRect">
             <a:avLst>
@@ -11662,14 +11810,14 @@
       </p:sp>
       <p:sp>
         <p:nvSpPr>
-          <p:cNvPr id="19" name="Rounded Rectangle 18"/>
+          <p:cNvPr id="22" name="Rounded Rectangle 21"/>
           <p:cNvSpPr/>
           <p:nvPr/>
         </p:nvSpPr>
         <p:spPr>
           <a:xfrm>
-            <a:off x="4251960" y="4526280"/>
-            <a:ext cx="685800" cy="502920"/>
+            <a:off x="4251960" y="5120640"/>
+            <a:ext cx="685800" cy="457200"/>
           </a:xfrm>
           <a:prstGeom prst="roundRect">
             <a:avLst>
@@ -11717,14 +11865,14 @@
       </p:sp>
       <p:sp>
         <p:nvSpPr>
-          <p:cNvPr id="20" name="Rounded Rectangle 19"/>
+          <p:cNvPr id="23" name="Rounded Rectangle 22"/>
           <p:cNvSpPr/>
           <p:nvPr/>
         </p:nvSpPr>
         <p:spPr>
           <a:xfrm>
-            <a:off x="4992624" y="4526280"/>
-            <a:ext cx="685800" cy="502920"/>
+            <a:off x="4992624" y="5120640"/>
+            <a:ext cx="685800" cy="457200"/>
           </a:xfrm>
           <a:prstGeom prst="roundRect">
             <a:avLst>
@@ -11772,14 +11920,14 @@
       </p:sp>
       <p:sp>
         <p:nvSpPr>
-          <p:cNvPr id="21" name="TextBox 20"/>
+          <p:cNvPr id="24" name="TextBox 23"/>
           <p:cNvSpPr txBox="1"/>
           <p:nvPr/>
         </p:nvSpPr>
         <p:spPr>
           <a:xfrm>
-            <a:off x="548640" y="5120640"/>
-            <a:ext cx="5212080" cy="1097280"/>
+            <a:off x="548640" y="5623560"/>
+            <a:ext cx="5212080" cy="731520"/>
           </a:xfrm>
           <a:prstGeom prst="rect">
             <a:avLst/>
@@ -11800,14 +11948,14 @@
                 </a:solidFill>
                 <a:latin typeface="Calibri"/>
               </a:rPr>
-              <a:t>Pick the config on 6 categories, score it on the 7th; repeat 7 times. Each file is scored once while held out. One global config, no per-file tuning.</a:t>
+              <a:t>The whole staged search runs on 6 categories; its pick is scored on the 7th. Run for 3 of 7 categories (cost); one global config, no per-file tuning.</a:t>
             </a:r>
           </a:p>
         </p:txBody>
       </p:sp>
       <p:graphicFrame>
         <p:nvGraphicFramePr>
-          <p:cNvPr id="22" name="Chart 21"/>
+          <p:cNvPr id="25" name="Chart 24"/>
           <p:cNvGraphicFramePr>
             <a:graphicFrameLocks noGrp="1"/>
           </p:cNvGraphicFramePr>
@@ -11825,7 +11973,7 @@
       </p:graphicFrame>
       <p:sp>
         <p:nvSpPr>
-          <p:cNvPr id="23" name="TextBox 22"/>
+          <p:cNvPr id="26" name="TextBox 25"/>
           <p:cNvSpPr txBox="1"/>
           <p:nvPr/>
         </p:nvSpPr>
@@ -11853,14 +12001,14 @@
                 </a:solidFill>
                 <a:latin typeface="Calibri"/>
               </a:rPr>
-              <a:t>Sentinel event F1 per category (windows found / windows). On the 5 no-anomaly files it raised 1 false alert.</a:t>
-            </a:r>
-          </a:p>
-        </p:txBody>
-      </p:sp>
-      <p:sp>
-        <p:nvSpPr>
-          <p:cNvPr id="24" name="TextBox 23"/>
+              <a:t>Sentinel trigger-based event F1 per category (windows found / windows), final config on all files. On the 5 no-anomaly files: 1 false alert.</a:t>
+            </a:r>
+          </a:p>
+        </p:txBody>
+      </p:sp>
+      <p:sp>
+        <p:nvSpPr>
+          <p:cNvPr id="27" name="TextBox 26"/>
           <p:cNvSpPr txBox="1"/>
           <p:nvPr/>
         </p:nvSpPr>
@@ -11895,7 +12043,7 @@
       </p:sp>
       <p:sp>
         <p:nvSpPr>
-          <p:cNvPr id="25" name="TextBox 24"/>
+          <p:cNvPr id="28" name="TextBox 27"/>
           <p:cNvSpPr txBox="1"/>
           <p:nvPr/>
         </p:nvSpPr>
@@ -11976,7 +12124,7 @@
                 </a:solidFill>
                 <a:latin typeface="Calibri"/>
               </a:rPr>
-              <a:t>Sentinel leads every baseline, even ones given our calibration</a:t>
+              <a:t>Results: Sentinel vs baselines on the same metric and protocol</a:t>
             </a:r>
           </a:p>
         </p:txBody>
@@ -12057,7 +12205,7 @@
                 </a:solidFill>
                 <a:latin typeface="Calibri"/>
               </a:rPr>
-              <a:t>0.53</a:t>
+              <a:t>0.48</a:t>
             </a:r>
           </a:p>
         </p:txBody>
@@ -12092,7 +12240,7 @@
                 </a:solidFill>
                 <a:latin typeface="Calibri"/>
               </a:rPr>
-              <a:t>event F1, all files (95% CI 0.45–0.61)</a:t>
+              <a:t>ET F1, all files (95% CI 0.38–0.56)</a:t>
             </a:r>
           </a:p>
         </p:txBody>
@@ -12173,7 +12321,7 @@
                 </a:solidFill>
                 <a:latin typeface="Calibri"/>
               </a:rPr>
-              <a:t>0.49</a:t>
+              <a:t>0.38</a:t>
             </a:r>
           </a:p>
         </p:txBody>
@@ -12208,7 +12356,7 @@
                 </a:solidFill>
                 <a:latin typeface="Calibri"/>
               </a:rPr>
-              <a:t>event F1, held-out categories (LOCO)</a:t>
+              <a:t>ET F1, held-out (nested LOCO, partial: 3 of 7 categories)</a:t>
             </a:r>
           </a:p>
         </p:txBody>
@@ -12289,7 +12437,7 @@
                 </a:solidFill>
                 <a:latin typeface="Calibri"/>
               </a:rPr>
-              <a:t>0.50 / 0.57</a:t>
+              <a:t>0.51 / 0.45</a:t>
             </a:r>
           </a:p>
         </p:txBody>
@@ -12324,7 +12472,7 @@
                 </a:solidFill>
                 <a:latin typeface="Calibri"/>
               </a:rPr>
-              <a:t>precision / recall (66/116 windows)</a:t>
+              <a:t>precision / recall (52/116 windows, 49 false)</a:t>
             </a:r>
           </a:p>
         </p:txBody>
@@ -12405,7 +12553,7 @@
                 </a:solidFill>
                 <a:latin typeface="Calibri"/>
               </a:rPr>
-              <a:t>44 µs</a:t>
+              <a:t>23 µs</a:t>
             </a:r>
           </a:p>
         </p:txBody>
@@ -12440,7 +12588,7 @@
                 </a:solidFill>
                 <a:latin typeface="Calibri"/>
               </a:rPr>
-              <a:t>per point, one laptop CPU core</a:t>
+              <a:t>per point, one CPU core</a:t>
             </a:r>
           </a:p>
         </p:txBody>
@@ -12455,7 +12603,7 @@
         </p:nvGraphicFramePr>
         <p:xfrm>
           <a:off x="548640" y="2697480"/>
-          <a:ext cx="11064240" cy="2560320"/>
+          <a:ext cx="11064239" cy="2560320"/>
         </p:xfrm>
         <a:graphic>
           <a:graphicData uri="http://schemas.openxmlformats.org/drawingml/2006/table">
@@ -12464,12 +12612,13 @@
                 <a:tableStyleId>{5C22544A-7EE6-4342-B048-85BDC9FD1C3A}</a:tableStyleId>
               </a:tblPr>
               <a:tblGrid>
-                <a:gridCol w="4206240"/>
+                <a:gridCol w="3749039"/>
+                <a:gridCol w="914400"/>
+                <a:gridCol w="1005840"/>
                 <a:gridCol w="1051560"/>
+                <a:gridCol w="914400"/>
                 <a:gridCol w="1234440"/>
-                <a:gridCol w="1097280"/>
-                <a:gridCol w="1005840"/>
-                <a:gridCol w="1188720"/>
+                <a:gridCol w="914400"/>
                 <a:gridCol w="1280160"/>
               </a:tblGrid>
               <a:tr h="365760">
@@ -12509,7 +12658,7 @@
                           </a:solidFill>
                           <a:latin typeface="Calibri"/>
                         </a:rPr>
-                        <a:t>Event F1</a:t>
+                        <a:t>ET F1</a:t>
                       </a:r>
                     </a:p>
                   </a:txBody>
@@ -12532,7 +12681,7 @@
                           </a:solidFill>
                           <a:latin typeface="Calibri"/>
                         </a:rPr>
-                        <a:t>LOCO-CV F1</a:t>
+                        <a:t>Held-out</a:t>
                       </a:r>
                     </a:p>
                   </a:txBody>
@@ -12624,7 +12773,30 @@
                           </a:solidFill>
                           <a:latin typeface="Calibri"/>
                         </a:rPr>
-                        <a:t>NAB*</a:t>
+                        <a:t>E1 F1</a:t>
+                      </a:r>
+                    </a:p>
+                  </a:txBody>
+                  <a:tcPr marL="73152" marR="73152" marT="27432" marB="27432" anchor="ctr">
+                    <a:solidFill>
+                      <a:srgbClr val="0F1B2D"/>
+                    </a:solidFill>
+                  </a:tcPr>
+                </a:tc>
+                <a:tc>
+                  <a:txBody>
+                    <a:bodyPr/>
+                    <a:lstStyle/>
+                    <a:p>
+                      <a:pPr algn="r"/>
+                      <a:r>
+                        <a:rPr sz="1200" b="1">
+                          <a:solidFill>
+                            <a:srgbClr val="FFFFFF"/>
+                          </a:solidFill>
+                          <a:latin typeface="Calibri"/>
+                        </a:rPr>
+                        <a:t>NAB</a:t>
                       </a:r>
                     </a:p>
                   </a:txBody>
@@ -12672,7 +12844,7 @@
                           </a:solidFill>
                           <a:latin typeface="Calibri"/>
                         </a:rPr>
-                        <a:t>0.532</a:t>
+                        <a:t>0.479</a:t>
                       </a:r>
                     </a:p>
                   </a:txBody>
@@ -12695,7 +12867,7 @@
                           </a:solidFill>
                           <a:latin typeface="Calibri"/>
                         </a:rPr>
-                        <a:t>0.486</a:t>
+                        <a:t>0.479</a:t>
                       </a:r>
                     </a:p>
                   </a:txBody>
@@ -12718,7 +12890,7 @@
                           </a:solidFill>
                           <a:latin typeface="Calibri"/>
                         </a:rPr>
-                        <a:t>0.500</a:t>
+                        <a:t>0.515</a:t>
                       </a:r>
                     </a:p>
                   </a:txBody>
@@ -12741,7 +12913,7 @@
                           </a:solidFill>
                           <a:latin typeface="Calibri"/>
                         </a:rPr>
-                        <a:t>0.569</a:t>
+                        <a:t>0.448</a:t>
                       </a:r>
                     </a:p>
                   </a:txBody>
@@ -12764,7 +12936,7 @@
                           </a:solidFill>
                           <a:latin typeface="Calibri"/>
                         </a:rPr>
-                        <a:t>74</a:t>
+                        <a:t>49</a:t>
                       </a:r>
                     </a:p>
                   </a:txBody>
@@ -12787,7 +12959,30 @@
                           </a:solidFill>
                           <a:latin typeface="Calibri"/>
                         </a:rPr>
-                        <a:t>40.7</a:t>
+                        <a:t>0.479</a:t>
+                      </a:r>
+                    </a:p>
+                  </a:txBody>
+                  <a:tcPr marL="73152" marR="73152" marT="27432" marB="27432" anchor="ctr">
+                    <a:solidFill>
+                      <a:srgbClr val="EEF4FC"/>
+                    </a:solidFill>
+                  </a:tcPr>
+                </a:tc>
+                <a:tc>
+                  <a:txBody>
+                    <a:bodyPr/>
+                    <a:lstStyle/>
+                    <a:p>
+                      <a:pPr algn="r"/>
+                      <a:r>
+                        <a:rPr sz="1200" b="1">
+                          <a:solidFill>
+                            <a:srgbClr val="0B0B0B"/>
+                          </a:solidFill>
+                          <a:latin typeface="Calibri"/>
+                        </a:rPr>
+                        <a:t>38.8</a:t>
                       </a:r>
                     </a:p>
                   </a:txBody>
@@ -12835,7 +13030,7 @@
                           </a:solidFill>
                           <a:latin typeface="Calibri"/>
                         </a:rPr>
-                        <a:t>0.494</a:t>
+                        <a:t>0.467</a:t>
                       </a:r>
                     </a:p>
                   </a:txBody>
@@ -12858,7 +13053,7 @@
                           </a:solidFill>
                           <a:latin typeface="Calibri"/>
                         </a:rPr>
-                        <a:t>0.471</a:t>
+                        <a:t>0.467</a:t>
                       </a:r>
                     </a:p>
                   </a:txBody>
@@ -12881,7 +13076,7 @@
                           </a:solidFill>
                           <a:latin typeface="Calibri"/>
                         </a:rPr>
-                        <a:t>0.452</a:t>
+                        <a:t>0.510</a:t>
                       </a:r>
                     </a:p>
                   </a:txBody>
@@ -12904,7 +13099,7 @@
                           </a:solidFill>
                           <a:latin typeface="Calibri"/>
                         </a:rPr>
-                        <a:t>0.543</a:t>
+                        <a:t>0.431</a:t>
                       </a:r>
                     </a:p>
                   </a:txBody>
@@ -12927,7 +13122,7 @@
                           </a:solidFill>
                           <a:latin typeface="Calibri"/>
                         </a:rPr>
-                        <a:t>86</a:t>
+                        <a:t>48</a:t>
                       </a:r>
                     </a:p>
                   </a:txBody>
@@ -12950,7 +13145,30 @@
                           </a:solidFill>
                           <a:latin typeface="Calibri"/>
                         </a:rPr>
-                        <a:t>43.1</a:t>
+                        <a:t>0.467</a:t>
+                      </a:r>
+                    </a:p>
+                  </a:txBody>
+                  <a:tcPr marL="73152" marR="73152" marT="27432" marB="27432" anchor="ctr">
+                    <a:solidFill>
+                      <a:srgbClr val="F7F7F5"/>
+                    </a:solidFill>
+                  </a:tcPr>
+                </a:tc>
+                <a:tc>
+                  <a:txBody>
+                    <a:bodyPr/>
+                    <a:lstStyle/>
+                    <a:p>
+                      <a:pPr algn="r"/>
+                      <a:r>
+                        <a:rPr sz="1200">
+                          <a:solidFill>
+                            <a:srgbClr val="52514E"/>
+                          </a:solidFill>
+                          <a:latin typeface="Calibri"/>
+                        </a:rPr>
+                        <a:t>36.7</a:t>
                       </a:r>
                     </a:p>
                   </a:txBody>
@@ -12998,7 +13216,7 @@
                           </a:solidFill>
                           <a:latin typeface="Calibri"/>
                         </a:rPr>
-                        <a:t>0.458</a:t>
+                        <a:t>0.383</a:t>
                       </a:r>
                     </a:p>
                   </a:txBody>
@@ -13021,7 +13239,7 @@
                           </a:solidFill>
                           <a:latin typeface="Calibri"/>
                         </a:rPr>
-                        <a:t>0.458</a:t>
+                        <a:t>0.353</a:t>
                       </a:r>
                     </a:p>
                   </a:txBody>
@@ -13044,7 +13262,7 @@
                           </a:solidFill>
                           <a:latin typeface="Calibri"/>
                         </a:rPr>
-                        <a:t>0.347</a:t>
+                        <a:t>0.288</a:t>
                       </a:r>
                     </a:p>
                   </a:txBody>
@@ -13067,7 +13285,7 @@
                           </a:solidFill>
                           <a:latin typeface="Calibri"/>
                         </a:rPr>
-                        <a:t>0.672</a:t>
+                        <a:t>0.569</a:t>
                       </a:r>
                     </a:p>
                   </a:txBody>
@@ -13090,7 +13308,7 @@
                           </a:solidFill>
                           <a:latin typeface="Calibri"/>
                         </a:rPr>
-                        <a:t>188</a:t>
+                        <a:t>163</a:t>
                       </a:r>
                     </a:p>
                   </a:txBody>
@@ -13113,7 +13331,30 @@
                           </a:solidFill>
                           <a:latin typeface="Calibri"/>
                         </a:rPr>
-                        <a:t>51.2</a:t>
+                        <a:t>0.385</a:t>
+                      </a:r>
+                    </a:p>
+                  </a:txBody>
+                  <a:tcPr marL="73152" marR="73152" marT="27432" marB="27432" anchor="ctr">
+                    <a:solidFill>
+                      <a:srgbClr val="FFFFFF"/>
+                    </a:solidFill>
+                  </a:tcPr>
+                </a:tc>
+                <a:tc>
+                  <a:txBody>
+                    <a:bodyPr/>
+                    <a:lstStyle/>
+                    <a:p>
+                      <a:pPr algn="r"/>
+                      <a:r>
+                        <a:rPr sz="1200">
+                          <a:solidFill>
+                            <a:srgbClr val="52514E"/>
+                          </a:solidFill>
+                          <a:latin typeface="Calibri"/>
+                        </a:rPr>
+                        <a:t>44.4</a:t>
                       </a:r>
                     </a:p>
                   </a:txBody>
@@ -13138,7 +13379,7 @@
                           </a:solidFill>
                           <a:latin typeface="Calibri"/>
                         </a:rPr>
-                        <a:t>One-Class SVM (+ our calibration &amp; event logic)</a:t>
+                        <a:t>Rolling z-score (+ our calibration &amp; event logic)</a:t>
                       </a:r>
                     </a:p>
                   </a:txBody>
@@ -13161,7 +13402,7 @@
                           </a:solidFill>
                           <a:latin typeface="Calibri"/>
                         </a:rPr>
-                        <a:t>0.390</a:t>
+                        <a:t>0.332</a:t>
                       </a:r>
                     </a:p>
                   </a:txBody>
@@ -13184,7 +13425,7 @@
                           </a:solidFill>
                           <a:latin typeface="Calibri"/>
                         </a:rPr>
-                        <a:t>0.372</a:t>
+                        <a:t>0.332</a:t>
                       </a:r>
                     </a:p>
                   </a:txBody>
@@ -13207,7 +13448,7 @@
                           </a:solidFill>
                           <a:latin typeface="Calibri"/>
                         </a:rPr>
-                        <a:t>0.288</a:t>
+                        <a:t>0.295</a:t>
                       </a:r>
                     </a:p>
                   </a:txBody>
@@ -13230,7 +13471,7 @@
                           </a:solidFill>
                           <a:latin typeface="Calibri"/>
                         </a:rPr>
-                        <a:t>0.603</a:t>
+                        <a:t>0.379</a:t>
                       </a:r>
                     </a:p>
                   </a:txBody>
@@ -13253,7 +13494,7 @@
                           </a:solidFill>
                           <a:latin typeface="Calibri"/>
                         </a:rPr>
-                        <a:t>220</a:t>
+                        <a:t>105</a:t>
                       </a:r>
                     </a:p>
                   </a:txBody>
@@ -13276,7 +13517,30 @@
                           </a:solidFill>
                           <a:latin typeface="Calibri"/>
                         </a:rPr>
-                        <a:t>39.4</a:t>
+                        <a:t>0.332</a:t>
+                      </a:r>
+                    </a:p>
+                  </a:txBody>
+                  <a:tcPr marL="73152" marR="73152" marT="27432" marB="27432" anchor="ctr">
+                    <a:solidFill>
+                      <a:srgbClr val="F7F7F5"/>
+                    </a:solidFill>
+                  </a:tcPr>
+                </a:tc>
+                <a:tc>
+                  <a:txBody>
+                    <a:bodyPr/>
+                    <a:lstStyle/>
+                    <a:p>
+                      <a:pPr algn="r"/>
+                      <a:r>
+                        <a:rPr sz="1200">
+                          <a:solidFill>
+                            <a:srgbClr val="52514E"/>
+                          </a:solidFill>
+                          <a:latin typeface="Calibri"/>
+                        </a:rPr>
+                        <a:t>29.6</a:t>
                       </a:r>
                     </a:p>
                   </a:txBody>
@@ -13301,7 +13565,7 @@
                           </a:solidFill>
                           <a:latin typeface="Calibri"/>
                         </a:rPr>
-                        <a:t>Rolling z-score (+ our calibration &amp; event logic)</a:t>
+                        <a:t>One-Class SVM (+ our calibration &amp; event logic)</a:t>
                       </a:r>
                     </a:p>
                   </a:txBody>
@@ -13324,7 +13588,7 @@
                           </a:solidFill>
                           <a:latin typeface="Calibri"/>
                         </a:rPr>
-                        <a:t>0.350</a:t>
+                        <a:t>0.307</a:t>
                       </a:r>
                     </a:p>
                   </a:txBody>
@@ -13347,7 +13611,7 @@
                           </a:solidFill>
                           <a:latin typeface="Calibri"/>
                         </a:rPr>
-                        <a:t>0.350</a:t>
+                        <a:t>0.307</a:t>
                       </a:r>
                     </a:p>
                   </a:txBody>
@@ -13370,7 +13634,7 @@
                           </a:solidFill>
                           <a:latin typeface="Calibri"/>
                         </a:rPr>
-                        <a:t>0.299</a:t>
+                        <a:t>0.266</a:t>
                       </a:r>
                     </a:p>
                   </a:txBody>
@@ -13393,7 +13657,7 @@
                           </a:solidFill>
                           <a:latin typeface="Calibri"/>
                         </a:rPr>
-                        <a:t>0.422</a:t>
+                        <a:t>0.362</a:t>
                       </a:r>
                     </a:p>
                   </a:txBody>
@@ -13416,7 +13680,7 @@
                           </a:solidFill>
                           <a:latin typeface="Calibri"/>
                         </a:rPr>
-                        <a:t>131</a:t>
+                        <a:t>116</a:t>
                       </a:r>
                     </a:p>
                   </a:txBody>
@@ -13439,7 +13703,30 @@
                           </a:solidFill>
                           <a:latin typeface="Calibri"/>
                         </a:rPr>
-                        <a:t>32.4</a:t>
+                        <a:t>0.307</a:t>
+                      </a:r>
+                    </a:p>
+                  </a:txBody>
+                  <a:tcPr marL="73152" marR="73152" marT="27432" marB="27432" anchor="ctr">
+                    <a:solidFill>
+                      <a:srgbClr val="FFFFFF"/>
+                    </a:solidFill>
+                  </a:tcPr>
+                </a:tc>
+                <a:tc>
+                  <a:txBody>
+                    <a:bodyPr/>
+                    <a:lstStyle/>
+                    <a:p>
+                      <a:pPr algn="r"/>
+                      <a:r>
+                        <a:rPr sz="1200">
+                          <a:solidFill>
+                            <a:srgbClr val="52514E"/>
+                          </a:solidFill>
+                          <a:latin typeface="Calibri"/>
+                        </a:rPr>
+                        <a:t>27.8</a:t>
                       </a:r>
                     </a:p>
                   </a:txBody>
@@ -13464,7 +13751,7 @@
                           </a:solidFill>
                           <a:latin typeface="Calibri"/>
                         </a:rPr>
-                        <a:t>Random (plain threshold)</a:t>
+                        <a:t>Random (+ event logic)</a:t>
                       </a:r>
                     </a:p>
                   </a:txBody>
@@ -13487,7 +13774,7 @@
                           </a:solidFill>
                           <a:latin typeface="Calibri"/>
                         </a:rPr>
-                        <a:t>0.186</a:t>
+                        <a:t>0.126</a:t>
                       </a:r>
                     </a:p>
                   </a:txBody>
@@ -13533,7 +13820,7 @@
                           </a:solidFill>
                           <a:latin typeface="Calibri"/>
                         </a:rPr>
-                        <a:t>0.103</a:t>
+                        <a:t>0.069</a:t>
                       </a:r>
                     </a:p>
                   </a:txBody>
@@ -13556,7 +13843,7 @@
                           </a:solidFill>
                           <a:latin typeface="Calibri"/>
                         </a:rPr>
-                        <a:t>0.931</a:t>
+                        <a:t>0.724</a:t>
                       </a:r>
                     </a:p>
                   </a:txBody>
@@ -13579,7 +13866,7 @@
                           </a:solidFill>
                           <a:latin typeface="Calibri"/>
                         </a:rPr>
-                        <a:t>4301</a:t>
+                        <a:t>1137</a:t>
                       </a:r>
                     </a:p>
                   </a:txBody>
@@ -13602,7 +13889,30 @@
                           </a:solidFill>
                           <a:latin typeface="Calibri"/>
                         </a:rPr>
-                        <a:t>-108.3</a:t>
+                        <a:t>0.178</a:t>
+                      </a:r>
+                    </a:p>
+                  </a:txBody>
+                  <a:tcPr marL="73152" marR="73152" marT="27432" marB="27432" anchor="ctr">
+                    <a:solidFill>
+                      <a:srgbClr val="F7F7F5"/>
+                    </a:solidFill>
+                  </a:tcPr>
+                </a:tc>
+                <a:tc>
+                  <a:txBody>
+                    <a:bodyPr/>
+                    <a:lstStyle/>
+                    <a:p>
+                      <a:pPr algn="r"/>
+                      <a:r>
+                        <a:rPr sz="1200">
+                          <a:solidFill>
+                            <a:srgbClr val="52514E"/>
+                          </a:solidFill>
+                          <a:latin typeface="Calibri"/>
+                        </a:rPr>
+                        <a:t>14.0</a:t>
                       </a:r>
                     </a:p>
                   </a:txBody>
@@ -13641,13 +13951,13 @@
           <a:p>
             <a:pPr algn="l"/>
             <a:r>
-              <a:rPr sz="1100" b="0" i="0">
+              <a:rPr sz="1050" b="0" i="0">
                 <a:solidFill>
                   <a:srgbClr val="898781"/>
                 </a:solidFill>
                 <a:latin typeface="Calibri"/>
               </a:rPr>
-              <a:t>Best variant of each baseline shown (full table: results/baselines_comparison.csv). LOCO-CV: threshold chosen on 6 categories, scored on the 7th. *NAB score at our operating point (alert onsets as detections). NAB's scoreboard (ARTime 74.9, HTM ~70, CAD OSE 69.9) tunes a threshold per detector and is a different metric.</a:t>
+              <a:t>Best variant of each baseline (full table: results/baselines_comparison.csv). Held-out column: θ chosen on 6 categories, scored on the 7th, for every method (Sentinel's other settings were tuned on all files). NAB = NAB standard score, every ANOMALOUS row a detection (checked against NAB's own code). Published NAB detectors, ET F1 at their NAB threshold: CAD OSE 0.68, HTM 0.53, ARTime 0.48; not causal (NAB gives each file's min/max in advance) and thresholds tuned on all labels.</a:t>
             </a:r>
           </a:p>
         </p:txBody>
@@ -13827,7 +14137,7 @@
         <p:spPr>
           <a:xfrm>
             <a:off x="548640" y="1508760"/>
-            <a:ext cx="5705856" cy="4754880"/>
+            <a:ext cx="7607808" cy="4754880"/>
           </a:xfrm>
           <a:prstGeom prst="rect">
             <a:avLst/>
@@ -13919,7 +14229,7 @@
                 </a:solidFill>
                 <a:latin typeface="Calibri"/>
               </a:rPr>
-              <a:t>  ·  ec2_cpu_utilization_825cc2.csv  ·  2014-04-16 03:34:00</a:t>
+              <a:t>  ·  ec2_cpu_utilization_825cc2.csv  ·  2014-04-15 16:59:00</a:t>
             </a:r>
           </a:p>
         </p:txBody>
@@ -13954,7 +14264,7 @@
                 </a:solidFill>
                 <a:latin typeface="Calibri"/>
               </a:rPr>
-              <a:t>Value 24.43 is 21.9x the normal spread below the expected 92.51.</a:t>
+              <a:t>Value 54.78 is 9.8x the normal spread below the expected 93.78. Also: Sustained downward shift: recent mean 85.91 vs baseline 93.32 for 38 points.</a:t>
             </a:r>
           </a:p>
         </p:txBody>
@@ -14169,7 +14479,7 @@
                 </a:solidFill>
                 <a:latin typeface="Calibri"/>
               </a:rPr>
-              <a:t>  ·  art_daily_jumpsdown.csv  ·  2014-04-12 10:35:00</a:t>
+              <a:t>  ·  art_noisy.csv  ·  2014-04-04 22:10:00</a:t>
             </a:r>
           </a:p>
         </p:txBody>
@@ -14204,7 +14514,7 @@
                 </a:solidFill>
                 <a:latin typeface="Calibri"/>
               </a:rPr>
-              <a:t>Sustained upward shift: recent mean 72.67 vs baseline 32.23 for 20 points.</a:t>
+              <a:t>Variance change: values became much more spread out around the baseline 13.55 over 41 points.</a:t>
             </a:r>
           </a:p>
           <a:p>
@@ -14216,7 +14526,7 @@
                 </a:solidFill>
                 <a:latin typeface="Calibri"/>
               </a:rPr>
-              <a:t>After the real anomaly the change detector re-baselined onto the night-time level, so the next normal daily rise looked like a shift.</a:t>
+              <a:t>This file is pure noise with no anomaly (NAB artificialNoAnomaly): the variance CUSUM crossed θ on a chance run of wide swings. False alerts on the 5 anomaly-free files: 1.</a:t>
             </a:r>
           </a:p>
         </p:txBody>

</xml_diff>

<commit_message>
Compiled LOF uses the reference's BLAS calls (bit-identical, 20.9 us/point); same-machine v2 benchmark; slides fixed (4 detectors, title); v3 demo screenshot; ablation variants derived from the final config
</commit_message>
<xml_diff>
--- a/slides/Sentinel_Challenge2.pptx
+++ b/slides/Sentinel_Challenge2.pptx
@@ -223,13 +223,13 @@
                   <c:v>D2 change only</c:v>
                 </c:pt>
                 <c:pt idx="2">
-                  <c:v>D3 shape only</c:v>
+                  <c:v>D7 subspace only</c:v>
                 </c:pt>
                 <c:pt idx="3">
-                  <c:v>D1 + D2 + D3 (shape on)</c:v>
+                  <c:v>D1 + D2 (v2 detectors)</c:v>
                 </c:pt>
                 <c:pt idx="4">
-                  <c:v>D1 + D2, no calibration</c:v>
+                  <c:v>D1 + D2 + D7, no calibration (raw / probation p99)</c:v>
                 </c:pt>
                 <c:pt idx="5">
                   <c:v>+ calibration, plain threshold</c:v>
@@ -238,10 +238,10 @@
                   <c:v>+ hysteresis</c:v>
                 </c:pt>
                 <c:pt idx="7">
-                  <c:v>+ cooldown, max length</c:v>
+                  <c:v>+ cooldown and max length</c:v>
                 </c:pt>
                 <c:pt idx="8">
-                  <c:v>+ pause, re-baseline (full)</c:v>
+                  <c:v>+ pause and re-baseline (full Sentinel, D1 + D2 + D7)</c:v>
                 </c:pt>
               </c:strCache>
             </c:strRef>
@@ -253,31 +253,31 @@
                 <c:formatCode>General</c:formatCode>
                 <c:ptCount val="9"/>
                 <c:pt idx="0">
-                  <c:v>0.417</c:v>
+                  <c:v>0.515</c:v>
                 </c:pt>
                 <c:pt idx="1">
+                  <c:v>0.469</c:v>
+                </c:pt>
+                <c:pt idx="2">
+                  <c:v>0.517</c:v>
+                </c:pt>
+                <c:pt idx="3">
+                  <c:v>0.523</c:v>
+                </c:pt>
+                <c:pt idx="4">
                   <c:v>0.422</c:v>
                 </c:pt>
-                <c:pt idx="2">
-                  <c:v>0.176</c:v>
-                </c:pt>
-                <c:pt idx="3">
-                  <c:v>0.465</c:v>
-                </c:pt>
-                <c:pt idx="4">
-                  <c:v>0.429</c:v>
-                </c:pt>
                 <c:pt idx="5">
-                  <c:v>0.472</c:v>
+                  <c:v>0.496</c:v>
                 </c:pt>
                 <c:pt idx="6">
-                  <c:v>0.477</c:v>
+                  <c:v>0.515</c:v>
                 </c:pt>
                 <c:pt idx="7">
-                  <c:v>0.475</c:v>
+                  <c:v>0.548</c:v>
                 </c:pt>
                 <c:pt idx="8">
-                  <c:v>0.479</c:v>
+                  <c:v>0.541</c:v>
                 </c:pt>
               </c:numCache>
             </c:numRef>
@@ -290,7 +290,7 @@
             <a:lstStyle/>
             <a:p>
               <a:pPr>
-                <a:defRPr sz="1100">
+                <a:defRPr sz="1000">
                   <a:solidFill>
                     <a:srgbClr val="0B0B0B"/>
                   </a:solidFill>
@@ -331,7 +331,7 @@
           <a:lstStyle/>
           <a:p>
             <a:pPr>
-              <a:defRPr sz="1100">
+              <a:defRPr sz="1000">
                 <a:solidFill>
                   <a:srgbClr val="52514E"/>
                 </a:solidFill>
@@ -349,7 +349,7 @@
       <c:valAx>
         <c:axId val="-2113994440"/>
         <c:scaling>
-          <c:max val="0.599078341013825"/>
+          <c:max val="0.6854838709677419"/>
           <c:min val="0.0"/>
         </c:scaling>
         <c:delete/>
@@ -368,7 +368,7 @@
     <a:lstStyle/>
     <a:p>
       <a:pPr>
-        <a:defRPr sz="1100">
+        <a:defRPr sz="1000">
           <a:solidFill>
             <a:srgbClr val="52514E"/>
           </a:solidFill>
@@ -464,19 +464,19 @@
                   <c:v>Artificial (4/6)</c:v>
                 </c:pt>
                 <c:pt idx="1">
-                  <c:v>Tweets (21/33)</c:v>
+                  <c:v>AWS (15/30)</c:v>
                 </c:pt>
                 <c:pt idx="2">
-                  <c:v>AWS (13/30)</c:v>
+                  <c:v>Tweets (19/33)</c:v>
                 </c:pt>
                 <c:pt idx="3">
-                  <c:v>Ad exchange (4/14)</c:v>
+                  <c:v>Ad exchange (5/14)</c:v>
                 </c:pt>
                 <c:pt idx="4">
-                  <c:v>Known cause (7/19)</c:v>
+                  <c:v>Traffic (4/14)</c:v>
                 </c:pt>
                 <c:pt idx="5">
-                  <c:v>Traffic (3/14)</c:v>
+                  <c:v>Known cause (9/19)</c:v>
                 </c:pt>
               </c:strCache>
             </c:strRef>
@@ -488,22 +488,22 @@
                 <c:formatCode>General</c:formatCode>
                 <c:ptCount val="6"/>
                 <c:pt idx="0">
-                  <c:v>0.8</c:v>
+                  <c:v>0.727</c:v>
                 </c:pt>
                 <c:pt idx="1">
-                  <c:v>0.545</c:v>
+                  <c:v>0.6</c:v>
                 </c:pt>
                 <c:pt idx="2">
-                  <c:v>0.5</c:v>
+                  <c:v>0.594</c:v>
                 </c:pt>
                 <c:pt idx="3">
-                  <c:v>0.4</c:v>
+                  <c:v>0.455</c:v>
                 </c:pt>
                 <c:pt idx="4">
-                  <c:v>0.368</c:v>
+                  <c:v>0.444</c:v>
                 </c:pt>
                 <c:pt idx="5">
-                  <c:v>0.316</c:v>
+                  <c:v>0.429</c:v>
                 </c:pt>
               </c:numCache>
             </c:numRef>
@@ -1355,7 +1355,7 @@
           <a:lstStyle/>
           <a:p>
             <a:r>
-              <a:t>All three raw scores live on different scales. Calibration turns each into a p-value against its own recent normal history, so one threshold means the same on every file.</a:t>
+              <a:t>The raw scores live on different scales. Calibration turns each into a p-value against its own recent normal history, so one threshold means the same on every file.</a:t>
             </a:r>
           </a:p>
         </p:txBody>
@@ -1425,7 +1425,7 @@
           <a:lstStyle/>
           <a:p>
             <a:r>
-              <a:t>Each stage keeps the best of the previous one. The all-files F1 is optimistic; the nested LOCO number re-runs the whole search without the held-out category and is what a new category would see.</a:t>
+              <a:t>Adoption rule, fixed before the v3 runs: a candidate must beat the current system on held-out categories (θ chosen on six, scored on the seventh) and on the late half of every file (θ chosen on the early halves), and the paired bootstrap mean must be positive. Most candidates improved in-sample by 0.04–0.06 and still failed one of the two checks.</a:t>
             </a:r>
           </a:p>
         </p:txBody>
@@ -5294,7 +5294,7 @@
                 </a:solidFill>
                 <a:latin typeface="Calibri"/>
               </a:rPr>
-              <a:t>Compare with time-series foundation models</a:t>
+              <a:t>Retrain the neural channel on the GPU with more history (docs/GPU_TRAINING.md)</a:t>
             </a:r>
           </a:p>
         </p:txBody>
@@ -5368,7 +5368,7 @@
                 </a:solidFill>
                 <a:latin typeface="Calibri"/>
               </a:rPr>
-              <a:t>Two causal detectors (residual + CUSUM) + calibration + event logic: trigger-based event F1 0.48 on NAB, all files; 0.38 held-out (nested LOCO, partial: 3 of 7 categories).</a:t>
+              <a:t>4 causal detectors (residual + change + lof + subspace) + calibration + event logic: trigger-based event F1 0.54 on NAB, all files; 0.48 with θ chosen on held-out categories, 0.57 on the late halves.</a:t>
             </a:r>
           </a:p>
           <a:p>
@@ -5384,7 +5384,7 @@
                 </a:solidFill>
                 <a:latin typeface="Calibri"/>
               </a:rPr>
-              <a:t>One alert per incident, each with a reason; tens of microseconds per point.</a:t>
+              <a:t>One alert per incident, each with a reason; 21 µs per point compiled.</a:t>
             </a:r>
           </a:p>
           <a:p>
@@ -5400,7 +5400,7 @@
                 </a:solidFill>
                 <a:latin typeface="Calibri"/>
               </a:rPr>
-              <a:t>Metric audited; every number reproducible from one command per step.</a:t>
+              <a:t>Metric audited; every change adopted only under a fixed held-out rule.</a:t>
             </a:r>
           </a:p>
         </p:txBody>
@@ -7748,7 +7748,7 @@
         <p:spPr>
           <a:xfrm>
             <a:off x="6400800" y="1554480"/>
-            <a:ext cx="4841972" cy="4800600"/>
+            <a:ext cx="4846404" cy="4800600"/>
           </a:xfrm>
           <a:prstGeom prst="rect">
             <a:avLst/>
@@ -8058,7 +8058,7 @@
         <p:spPr>
           <a:xfrm>
             <a:off x="4352544" y="2057400"/>
-            <a:ext cx="1572768" cy="640080"/>
+            <a:ext cx="1572768" cy="452627"/>
           </a:xfrm>
           <a:prstGeom prst="roundRect">
             <a:avLst>
@@ -8088,12 +8088,12 @@
           </a:fontRef>
         </p:style>
         <p:txBody>
-          <a:bodyPr rtlCol="0" anchor="ctr" wrap="square" lIns="73152" rIns="73152" tIns="73152" bIns="73152"/>
+          <a:bodyPr rtlCol="0" anchor="ctr" wrap="square" lIns="54864" rIns="54864" tIns="54864" bIns="54864"/>
           <a:lstStyle/>
           <a:p>
             <a:pPr algn="l"/>
             <a:r>
-              <a:rPr sz="1300" b="1" i="0">
+              <a:rPr sz="1200" b="1" i="0">
                 <a:solidFill>
                   <a:srgbClr val="FFFFFF"/>
                 </a:solidFill>
@@ -8105,7 +8105,7 @@
           <a:p>
             <a:pPr algn="l"/>
             <a:r>
-              <a:rPr sz="1000" b="0" i="0">
+              <a:rPr sz="900" b="0" i="0">
                 <a:solidFill>
                   <a:srgbClr val="DCE8F8"/>
                 </a:solidFill>
@@ -8124,8 +8124,8 @@
         </p:nvSpPr>
         <p:spPr>
           <a:xfrm>
-            <a:off x="4352544" y="2788920"/>
-            <a:ext cx="1572768" cy="640080"/>
+            <a:off x="4352544" y="2583180"/>
+            <a:ext cx="1572768" cy="452627"/>
           </a:xfrm>
           <a:prstGeom prst="roundRect">
             <a:avLst>
@@ -8155,12 +8155,12 @@
           </a:fontRef>
         </p:style>
         <p:txBody>
-          <a:bodyPr rtlCol="0" anchor="ctr" wrap="square" lIns="73152" rIns="73152" tIns="73152" bIns="73152"/>
+          <a:bodyPr rtlCol="0" anchor="ctr" wrap="square" lIns="54864" rIns="54864" tIns="54864" bIns="54864"/>
           <a:lstStyle/>
           <a:p>
             <a:pPr algn="l"/>
             <a:r>
-              <a:rPr sz="1300" b="1" i="0">
+              <a:rPr sz="1200" b="1" i="0">
                 <a:solidFill>
                   <a:srgbClr val="FFFFFF"/>
                 </a:solidFill>
@@ -8172,7 +8172,7 @@
           <a:p>
             <a:pPr algn="l"/>
             <a:r>
-              <a:rPr sz="1000" b="0" i="0">
+              <a:rPr sz="900" b="0" i="0">
                 <a:solidFill>
                   <a:srgbClr val="DCE8F8"/>
                 </a:solidFill>
@@ -8191,8 +8191,8 @@
         </p:nvSpPr>
         <p:spPr>
           <a:xfrm>
-            <a:off x="4352544" y="3520440"/>
-            <a:ext cx="1572768" cy="640080"/>
+            <a:off x="4352544" y="3108960"/>
+            <a:ext cx="1572768" cy="452627"/>
           </a:xfrm>
           <a:prstGeom prst="roundRect">
             <a:avLst>
@@ -8222,30 +8222,30 @@
           </a:fontRef>
         </p:style>
         <p:txBody>
-          <a:bodyPr rtlCol="0" anchor="ctr" wrap="square" lIns="73152" rIns="73152" tIns="73152" bIns="73152"/>
+          <a:bodyPr rtlCol="0" anchor="ctr" wrap="square" lIns="54864" rIns="54864" tIns="54864" bIns="54864"/>
           <a:lstStyle/>
           <a:p>
             <a:pPr algn="l"/>
             <a:r>
-              <a:rPr sz="1300" b="1" i="0">
+              <a:rPr sz="1200" b="1" i="0">
                 <a:solidFill>
                   <a:srgbClr val="FFFFFF"/>
                 </a:solidFill>
                 <a:latin typeface="Calibri"/>
               </a:rPr>
-              <a:t>D3 Shape</a:t>
+              <a:t>D4 LOF</a:t>
             </a:r>
           </a:p>
           <a:p>
             <a:pPr algn="l"/>
             <a:r>
-              <a:rPr sz="1000" b="0" i="0">
+              <a:rPr sz="900" b="0" i="0">
                 <a:solidFill>
                   <a:srgbClr val="DCE8F8"/>
                 </a:solidFill>
                 <a:latin typeface="Calibri"/>
               </a:rPr>
-              <a:t>odd patterns (off in final.yaml)</a:t>
+              <a:t>unusual recent window</a:t>
             </a:r>
           </a:p>
         </p:txBody>
@@ -8253,6 +8253,73 @@
       <p:sp>
         <p:nvSpPr>
           <p:cNvPr id="9" name="Rounded Rectangle 8"/>
+          <p:cNvSpPr/>
+          <p:nvPr/>
+        </p:nvSpPr>
+        <p:spPr>
+          <a:xfrm>
+            <a:off x="4352544" y="3634739"/>
+            <a:ext cx="1572768" cy="452627"/>
+          </a:xfrm>
+          <a:prstGeom prst="roundRect">
+            <a:avLst>
+              <a:gd name="adj" fmla="val 8000"/>
+            </a:avLst>
+          </a:prstGeom>
+          <a:solidFill>
+            <a:srgbClr val="2A78D6"/>
+          </a:solidFill>
+          <a:ln>
+            <a:noFill/>
+          </a:ln>
+          <a:effectLst/>
+        </p:spPr>
+        <p:style>
+          <a:lnRef idx="1">
+            <a:schemeClr val="accent1"/>
+          </a:lnRef>
+          <a:fillRef idx="3">
+            <a:schemeClr val="accent1"/>
+          </a:fillRef>
+          <a:effectRef idx="2">
+            <a:schemeClr val="accent1"/>
+          </a:effectRef>
+          <a:fontRef idx="minor">
+            <a:schemeClr val="lt1"/>
+          </a:fontRef>
+        </p:style>
+        <p:txBody>
+          <a:bodyPr rtlCol="0" anchor="ctr" wrap="square" lIns="54864" rIns="54864" tIns="54864" bIns="54864"/>
+          <a:lstStyle/>
+          <a:p>
+            <a:pPr algn="l"/>
+            <a:r>
+              <a:rPr sz="1200" b="1" i="0">
+                <a:solidFill>
+                  <a:srgbClr val="FFFFFF"/>
+                </a:solidFill>
+                <a:latin typeface="Calibri"/>
+              </a:rPr>
+              <a:t>D7 Subspace</a:t>
+            </a:r>
+          </a:p>
+          <a:p>
+            <a:pPr algn="l"/>
+            <a:r>
+              <a:rPr sz="900" b="0" i="0">
+                <a:solidFill>
+                  <a:srgbClr val="DCE8F8"/>
+                </a:solidFill>
+                <a:latin typeface="Calibri"/>
+              </a:rPr>
+              <a:t>pattern breaks (SSA)</a:t>
+            </a:r>
+          </a:p>
+        </p:txBody>
+      </p:sp>
+      <p:sp>
+        <p:nvSpPr>
+          <p:cNvPr id="10" name="Rounded Rectangle 9"/>
           <p:cNvSpPr/>
           <p:nvPr/>
         </p:nvSpPr>
@@ -8320,7 +8387,7 @@
       </p:sp>
       <p:sp>
         <p:nvSpPr>
-          <p:cNvPr id="10" name="Rounded Rectangle 9"/>
+          <p:cNvPr id="11" name="Rounded Rectangle 10"/>
           <p:cNvSpPr/>
           <p:nvPr/>
         </p:nvSpPr>
@@ -8388,7 +8455,7 @@
       </p:sp>
       <p:sp>
         <p:nvSpPr>
-          <p:cNvPr id="11" name="Rounded Rectangle 10"/>
+          <p:cNvPr id="12" name="Rounded Rectangle 11"/>
           <p:cNvSpPr/>
           <p:nvPr/>
         </p:nvSpPr>
@@ -8455,49 +8522,13 @@
       </p:sp>
       <p:cxnSp>
         <p:nvCxnSpPr>
-          <p:cNvPr id="12" name="Connector 11"/>
-          <p:cNvCxnSpPr/>
-          <p:nvPr/>
-        </p:nvCxnSpPr>
-        <p:spPr>
-          <a:xfrm>
-            <a:off x="2157984" y="3108960"/>
-            <a:ext cx="256032" cy="0"/>
-          </a:xfrm>
-          <a:prstGeom prst="line">
-            <a:avLst/>
-          </a:prstGeom>
-          <a:ln w="19050">
-            <a:solidFill>
-              <a:srgbClr val="898781"/>
-            </a:solidFill>
-            <a:tailEnd type="triangle" w="med" len="med"/>
-          </a:ln>
-        </p:spPr>
-        <p:style>
-          <a:lnRef idx="2">
-            <a:schemeClr val="accent1"/>
-          </a:lnRef>
-          <a:fillRef idx="0">
-            <a:schemeClr val="accent1"/>
-          </a:fillRef>
-          <a:effectRef idx="1">
-            <a:schemeClr val="accent1"/>
-          </a:effectRef>
-          <a:fontRef idx="minor">
-            <a:schemeClr val="tx1"/>
-          </a:fontRef>
-        </p:style>
-      </p:cxnSp>
-      <p:cxnSp>
-        <p:nvCxnSpPr>
           <p:cNvPr id="13" name="Connector 12"/>
           <p:cNvCxnSpPr/>
           <p:nvPr/>
         </p:nvCxnSpPr>
         <p:spPr>
           <a:xfrm>
-            <a:off x="4059936" y="3108960"/>
+            <a:off x="2157984" y="3108960"/>
             <a:ext cx="256032" cy="0"/>
           </a:xfrm>
           <a:prstGeom prst="line">
@@ -8533,7 +8564,7 @@
         </p:nvCxnSpPr>
         <p:spPr>
           <a:xfrm>
-            <a:off x="5961888" y="3108960"/>
+            <a:off x="4059936" y="3108960"/>
             <a:ext cx="256032" cy="0"/>
           </a:xfrm>
           <a:prstGeom prst="line">
@@ -8569,7 +8600,7 @@
         </p:nvCxnSpPr>
         <p:spPr>
           <a:xfrm>
-            <a:off x="7863840" y="3108960"/>
+            <a:off x="5961888" y="3108960"/>
             <a:ext cx="256032" cy="0"/>
           </a:xfrm>
           <a:prstGeom prst="line">
@@ -8605,7 +8636,7 @@
         </p:nvCxnSpPr>
         <p:spPr>
           <a:xfrm>
-            <a:off x="9765792" y="3108960"/>
+            <a:off x="7863840" y="3108960"/>
             <a:ext cx="256032" cy="0"/>
           </a:xfrm>
           <a:prstGeom prst="line">
@@ -8633,9 +8664,45 @@
           </a:fontRef>
         </p:style>
       </p:cxnSp>
-      <p:sp>
-        <p:nvSpPr>
-          <p:cNvPr id="17" name="Rounded Rectangle 16"/>
+      <p:cxnSp>
+        <p:nvCxnSpPr>
+          <p:cNvPr id="17" name="Connector 16"/>
+          <p:cNvCxnSpPr/>
+          <p:nvPr/>
+        </p:nvCxnSpPr>
+        <p:spPr>
+          <a:xfrm>
+            <a:off x="9765792" y="3108960"/>
+            <a:ext cx="256032" cy="0"/>
+          </a:xfrm>
+          <a:prstGeom prst="line">
+            <a:avLst/>
+          </a:prstGeom>
+          <a:ln w="19050">
+            <a:solidFill>
+              <a:srgbClr val="898781"/>
+            </a:solidFill>
+            <a:tailEnd type="triangle" w="med" len="med"/>
+          </a:ln>
+        </p:spPr>
+        <p:style>
+          <a:lnRef idx="2">
+            <a:schemeClr val="accent1"/>
+          </a:lnRef>
+          <a:fillRef idx="0">
+            <a:schemeClr val="accent1"/>
+          </a:fillRef>
+          <a:effectRef idx="1">
+            <a:schemeClr val="accent1"/>
+          </a:effectRef>
+          <a:fontRef idx="minor">
+            <a:schemeClr val="tx1"/>
+          </a:fontRef>
+        </p:style>
+      </p:cxnSp>
+      <p:sp>
+        <p:nvSpPr>
+          <p:cNvPr id="18" name="Rounded Rectangle 17"/>
           <p:cNvSpPr/>
           <p:nvPr/>
         </p:nvSpPr>
@@ -8702,7 +8769,7 @@
       </p:sp>
       <p:cxnSp>
         <p:nvCxnSpPr>
-          <p:cNvPr id="18" name="Connector 17"/>
+          <p:cNvPr id="19" name="Connector 18"/>
           <p:cNvCxnSpPr/>
           <p:nvPr/>
         </p:nvCxnSpPr>
@@ -8738,7 +8805,7 @@
       </p:cxnSp>
       <p:sp>
         <p:nvSpPr>
-          <p:cNvPr id="19" name="TextBox 18"/>
+          <p:cNvPr id="20" name="TextBox 19"/>
           <p:cNvSpPr txBox="1"/>
           <p:nvPr/>
         </p:nvSpPr>
@@ -8773,7 +8840,7 @@
       </p:sp>
       <p:sp>
         <p:nvSpPr>
-          <p:cNvPr id="20" name="TextBox 19"/>
+          <p:cNvPr id="21" name="TextBox 20"/>
           <p:cNvSpPr txBox="1"/>
           <p:nvPr/>
         </p:nvSpPr>
@@ -8801,14 +8868,14 @@
                 </a:solidFill>
                 <a:latin typeface="Calibri"/>
               </a:rPr>
-              <a:t>D1 rolling median (sorted list) and D2 CUSUM per point</a:t>
-            </a:r>
-          </a:p>
-        </p:txBody>
-      </p:sp>
-      <p:sp>
-        <p:nvSpPr>
-          <p:cNvPr id="21" name="TextBox 20"/>
+              <a:t>D1 rolling median and D2 CUSUM per point; D7 one L×r projection</a:t>
+            </a:r>
+          </a:p>
+        </p:txBody>
+      </p:sp>
+      <p:sp>
+        <p:nvSpPr>
+          <p:cNvPr id="22" name="TextBox 21"/>
           <p:cNvSpPr txBox="1"/>
           <p:nvPr/>
         </p:nvSpPr>
@@ -8836,14 +8903,14 @@
                 </a:solidFill>
                 <a:latin typeface="Calibri"/>
               </a:rPr>
-              <a:t>O(H·m)</a:t>
-            </a:r>
-          </a:p>
-        </p:txBody>
-      </p:sp>
-      <p:sp>
-        <p:nvSpPr>
-          <p:cNvPr id="22" name="TextBox 21"/>
+              <a:t>181 µs</a:t>
+            </a:r>
+          </a:p>
+        </p:txBody>
+      </p:sp>
+      <p:sp>
+        <p:nvSpPr>
+          <p:cNvPr id="23" name="TextBox 22"/>
           <p:cNvSpPr txBox="1"/>
           <p:nvPr/>
         </p:nvSpPr>
@@ -8871,14 +8938,14 @@
                 </a:solidFill>
                 <a:latin typeface="Calibri"/>
               </a:rPr>
-              <a:t>D3: one matrix-vector product over the last H windows</a:t>
-            </a:r>
-          </a:p>
-        </p:txBody>
-      </p:sp>
-      <p:sp>
-        <p:nvSpPr>
-          <p:cNvPr id="23" name="TextBox 22"/>
+              <a:t>per point, streaming API (Python), p99 662 µs</a:t>
+            </a:r>
+          </a:p>
+        </p:txBody>
+      </p:sp>
+      <p:sp>
+        <p:nvSpPr>
+          <p:cNvPr id="24" name="TextBox 23"/>
           <p:cNvSpPr txBox="1"/>
           <p:nvPr/>
         </p:nvSpPr>
@@ -8906,14 +8973,14 @@
                 </a:solidFill>
                 <a:latin typeface="Calibri"/>
               </a:rPr>
-              <a:t>23 µs</a:t>
-            </a:r>
-          </a:p>
-        </p:txBody>
-      </p:sp>
-      <p:sp>
-        <p:nvSpPr>
-          <p:cNvPr id="24" name="TextBox 23"/>
+              <a:t>20.9 µs</a:t>
+            </a:r>
+          </a:p>
+        </p:txBody>
+      </p:sp>
+      <p:sp>
+        <p:nvSpPr>
+          <p:cNvPr id="25" name="TextBox 24"/>
           <p:cNvSpPr txBox="1"/>
           <p:nvPr/>
         </p:nvSpPr>
@@ -8941,14 +9008,14 @@
                 </a:solidFill>
                 <a:latin typeface="Calibri"/>
               </a:rPr>
-              <a:t>mean time per point, one CPU core (p99 183 µs)</a:t>
-            </a:r>
-          </a:p>
-        </p:txBody>
-      </p:sp>
-      <p:sp>
-        <p:nvSpPr>
-          <p:cNvPr id="25" name="TextBox 24"/>
+              <a:t>per point, compiled engine (Numba), identical output</a:t>
+            </a:r>
+          </a:p>
+        </p:txBody>
+      </p:sp>
+      <p:sp>
+        <p:nvSpPr>
+          <p:cNvPr id="26" name="TextBox 25"/>
           <p:cNvSpPr txBox="1"/>
           <p:nvPr/>
         </p:nvSpPr>
@@ -8983,7 +9050,7 @@
       </p:sp>
       <p:sp>
         <p:nvSpPr>
-          <p:cNvPr id="26" name="TextBox 25"/>
+          <p:cNvPr id="27" name="TextBox 26"/>
           <p:cNvSpPr txBox="1"/>
           <p:nvPr/>
         </p:nvSpPr>
@@ -9018,7 +9085,7 @@
       </p:sp>
       <p:sp>
         <p:nvSpPr>
-          <p:cNvPr id="27" name="TextBox 26"/>
+          <p:cNvPr id="28" name="TextBox 27"/>
           <p:cNvSpPr txBox="1"/>
           <p:nvPr/>
         </p:nvSpPr>
@@ -9053,7 +9120,7 @@
       </p:sp>
       <p:sp>
         <p:nvSpPr>
-          <p:cNvPr id="28" name="TextBox 27"/>
+          <p:cNvPr id="29" name="TextBox 28"/>
           <p:cNvSpPr txBox="1"/>
           <p:nvPr/>
         </p:nvSpPr>
@@ -9519,7 +9586,7 @@
                 </a:solidFill>
                 <a:latin typeface="Calibri"/>
               </a:rPr>
-              <a:t>D3  Shape</a:t>
+              <a:t>D7  Subspace</a:t>
             </a:r>
           </a:p>
         </p:txBody>
@@ -9554,7 +9621,7 @@
                 </a:solidFill>
                 <a:latin typeface="Calibri"/>
               </a:rPr>
-              <a:t>Unusual patterns (optional; off in final.yaml)</a:t>
+              <a:t>Pattern breaks the learning period never showed</a:t>
             </a:r>
           </a:p>
         </p:txBody>
@@ -9589,8 +9656,8 @@
                 </a:solidFill>
                 <a:latin typeface="Calibri"/>
               </a:rPr>
-              <a:t>distance of newest z-normalized 16-point window
-to its nearest of the last 1000 windows</a:t>
+              <a:t>newest 32-point window, minus its mean, outside the
+principal subspace of probation windows (90% variance): S7 = SPE / L</a:t>
             </a:r>
           </a:p>
         </p:txBody>
@@ -10031,7 +10098,7 @@
                 <a:latin typeface="Calibri"/>
               </a:rPr>
               <a:t>Ū ≥ θ_enter
-= 3.5</a:t>
+= 5.0</a:t>
             </a:r>
           </a:p>
         </p:txBody>
@@ -10066,7 +10133,7 @@
                 </a:solidFill>
                 <a:latin typeface="Calibri"/>
               </a:rPr>
-              <a:t>Ū &lt; 3.0 or
+              <a:t>Ū &lt; 4.5 or
 length ≥ 200</a:t>
             </a:r>
           </a:p>
@@ -10256,7 +10323,7 @@
                 </a:solidFill>
                 <a:latin typeface="Calibri"/>
               </a:rPr>
-              <a:t>U = max_k U_k − log10 K (Bonferroni, K = 2 detectors on); Ū = mean over 5 points</a:t>
+              <a:t>U = max_k U_k − log10 K (Bonferroni, K = 4 detectors on); Ū = mean over 5 points</a:t>
             </a:r>
           </a:p>
           <a:p>
@@ -10429,7 +10496,7 @@
                 </a:solidFill>
                 <a:latin typeface="Calibri"/>
               </a:rPr>
-              <a:t>Staged search, logged run by run, judged on held-out categories</a:t>
+              <a:t>Experiment log: v2 search, then v3 tests under a fixed rule</a:t>
             </a:r>
           </a:p>
         </p:txBody>
@@ -10464,7 +10531,7 @@
                 </a:solidFill>
                 <a:latin typeface="Calibri"/>
               </a:rPr>
-              <a:t>objective: trigger-based event F1; 231 configs in the final search, each run on all 58 files; every run in experiments/runs.csv</a:t>
+              <a:t>v2: 231 configs, staged grid, every run in experiments/runs.csv  ·  v3: each candidate family vs the current one on held-out categories AND on the late half of every file</a:t>
             </a:r>
           </a:p>
         </p:txBody>
@@ -10486,7 +10553,7 @@
         <p:spPr>
           <a:xfrm>
             <a:off x="548640" y="1508760"/>
-            <a:ext cx="5760720" cy="2804625"/>
+            <a:ext cx="4937760" cy="2403909"/>
           </a:xfrm>
           <a:prstGeom prst="rect">
             <a:avLst/>
@@ -10495,15 +10562,1097 @@
       </p:pic>
       <p:graphicFrame>
         <p:nvGraphicFramePr>
-          <p:cNvPr id="5" name="Chart 4"/>
+          <p:cNvPr id="5" name="Table 4"/>
           <p:cNvGraphicFramePr>
             <a:graphicFrameLocks noGrp="1"/>
           </p:cNvGraphicFramePr>
           <p:nvPr/>
         </p:nvGraphicFramePr>
         <p:xfrm>
-          <a:off x="6537960" y="1417320"/>
-          <a:ext cx="5120640" cy="3657600"/>
+          <a:off x="548640" y="3703320"/>
+          <a:ext cx="5394960" cy="2386584"/>
+        </p:xfrm>
+        <a:graphic>
+          <a:graphicData uri="http://schemas.openxmlformats.org/drawingml/2006/table">
+            <a:tbl>
+              <a:tblPr firstRow="1" bandRow="1">
+                <a:tableStyleId>{5C22544A-7EE6-4342-B048-85BDC9FD1C3A}</a:tableStyleId>
+              </a:tblPr>
+              <a:tblGrid>
+                <a:gridCol w="2240280"/>
+                <a:gridCol w="777240"/>
+                <a:gridCol w="777240"/>
+                <a:gridCol w="822960"/>
+                <a:gridCol w="777240"/>
+              </a:tblGrid>
+              <a:tr h="265176">
+                <a:tc>
+                  <a:txBody>
+                    <a:bodyPr/>
+                    <a:lstStyle/>
+                    <a:p>
+                      <a:pPr algn="l"/>
+                      <a:r>
+                        <a:rPr sz="1000" b="1">
+                          <a:solidFill>
+                            <a:srgbClr val="FFFFFF"/>
+                          </a:solidFill>
+                          <a:latin typeface="Calibri"/>
+                        </a:rPr>
+                        <a:t>v3 candidate (θ 3.5–5.5)</a:t>
+                      </a:r>
+                    </a:p>
+                  </a:txBody>
+                  <a:tcPr marL="73152" marR="73152" marT="27432" marB="27432" anchor="ctr">
+                    <a:solidFill>
+                      <a:srgbClr val="0F1B2D"/>
+                    </a:solidFill>
+                  </a:tcPr>
+                </a:tc>
+                <a:tc>
+                  <a:txBody>
+                    <a:bodyPr/>
+                    <a:lstStyle/>
+                    <a:p>
+                      <a:pPr algn="r"/>
+                      <a:r>
+                        <a:rPr sz="1000" b="1">
+                          <a:solidFill>
+                            <a:srgbClr val="FFFFFF"/>
+                          </a:solidFill>
+                          <a:latin typeface="Calibri"/>
+                        </a:rPr>
+                        <a:t>In-sample</a:t>
+                      </a:r>
+                    </a:p>
+                  </a:txBody>
+                  <a:tcPr marL="73152" marR="73152" marT="27432" marB="27432" anchor="ctr">
+                    <a:solidFill>
+                      <a:srgbClr val="0F1B2D"/>
+                    </a:solidFill>
+                  </a:tcPr>
+                </a:tc>
+                <a:tc>
+                  <a:txBody>
+                    <a:bodyPr/>
+                    <a:lstStyle/>
+                    <a:p>
+                      <a:pPr algn="r"/>
+                      <a:r>
+                        <a:rPr sz="1000" b="1">
+                          <a:solidFill>
+                            <a:srgbClr val="FFFFFF"/>
+                          </a:solidFill>
+                          <a:latin typeface="Calibri"/>
+                        </a:rPr>
+                        <a:t>θ-LOCO</a:t>
+                      </a:r>
+                    </a:p>
+                  </a:txBody>
+                  <a:tcPr marL="73152" marR="73152" marT="27432" marB="27432" anchor="ctr">
+                    <a:solidFill>
+                      <a:srgbClr val="0F1B2D"/>
+                    </a:solidFill>
+                  </a:tcPr>
+                </a:tc>
+                <a:tc>
+                  <a:txBody>
+                    <a:bodyPr/>
+                    <a:lstStyle/>
+                    <a:p>
+                      <a:pPr algn="r"/>
+                      <a:r>
+                        <a:rPr sz="1000" b="1">
+                          <a:solidFill>
+                            <a:srgbClr val="FFFFFF"/>
+                          </a:solidFill>
+                          <a:latin typeface="Calibri"/>
+                        </a:rPr>
+                        <a:t>Late half</a:t>
+                      </a:r>
+                    </a:p>
+                  </a:txBody>
+                  <a:tcPr marL="73152" marR="73152" marT="27432" marB="27432" anchor="ctr">
+                    <a:solidFill>
+                      <a:srgbClr val="0F1B2D"/>
+                    </a:solidFill>
+                  </a:tcPr>
+                </a:tc>
+                <a:tc>
+                  <a:txBody>
+                    <a:bodyPr/>
+                    <a:lstStyle/>
+                    <a:p>
+                      <a:pPr algn="r"/>
+                      <a:r>
+                        <a:rPr sz="1000" b="1">
+                          <a:solidFill>
+                            <a:srgbClr val="FFFFFF"/>
+                          </a:solidFill>
+                          <a:latin typeface="Calibri"/>
+                        </a:rPr>
+                        <a:t/>
+                      </a:r>
+                    </a:p>
+                  </a:txBody>
+                  <a:tcPr marL="73152" marR="73152" marT="27432" marB="27432" anchor="ctr">
+                    <a:solidFill>
+                      <a:srgbClr val="0F1B2D"/>
+                    </a:solidFill>
+                  </a:tcPr>
+                </a:tc>
+              </a:tr>
+              <a:tr h="265176">
+                <a:tc>
+                  <a:txBody>
+                    <a:bodyPr/>
+                    <a:lstStyle/>
+                    <a:p>
+                      <a:pPr algn="l"/>
+                      <a:r>
+                        <a:rPr sz="1000">
+                          <a:solidFill>
+                            <a:srgbClr val="52514E"/>
+                          </a:solidFill>
+                          <a:latin typeface="Calibri"/>
+                        </a:rPr>
+                        <a:t>current (D1 + D2)</a:t>
+                      </a:r>
+                    </a:p>
+                  </a:txBody>
+                  <a:tcPr marL="73152" marR="73152" marT="27432" marB="27432" anchor="ctr">
+                    <a:solidFill>
+                      <a:srgbClr val="FFFFFF"/>
+                    </a:solidFill>
+                  </a:tcPr>
+                </a:tc>
+                <a:tc>
+                  <a:txBody>
+                    <a:bodyPr/>
+                    <a:lstStyle/>
+                    <a:p>
+                      <a:pPr algn="r"/>
+                      <a:r>
+                        <a:rPr sz="1000">
+                          <a:solidFill>
+                            <a:srgbClr val="52514E"/>
+                          </a:solidFill>
+                          <a:latin typeface="Calibri"/>
+                        </a:rPr>
+                        <a:t>0.479</a:t>
+                      </a:r>
+                    </a:p>
+                  </a:txBody>
+                  <a:tcPr marL="73152" marR="73152" marT="27432" marB="27432" anchor="ctr">
+                    <a:solidFill>
+                      <a:srgbClr val="FFFFFF"/>
+                    </a:solidFill>
+                  </a:tcPr>
+                </a:tc>
+                <a:tc>
+                  <a:txBody>
+                    <a:bodyPr/>
+                    <a:lstStyle/>
+                    <a:p>
+                      <a:pPr algn="r"/>
+                      <a:r>
+                        <a:rPr sz="1000">
+                          <a:solidFill>
+                            <a:srgbClr val="52514E"/>
+                          </a:solidFill>
+                          <a:latin typeface="Calibri"/>
+                        </a:rPr>
+                        <a:t>0.479</a:t>
+                      </a:r>
+                    </a:p>
+                  </a:txBody>
+                  <a:tcPr marL="73152" marR="73152" marT="27432" marB="27432" anchor="ctr">
+                    <a:solidFill>
+                      <a:srgbClr val="FFFFFF"/>
+                    </a:solidFill>
+                  </a:tcPr>
+                </a:tc>
+                <a:tc>
+                  <a:txBody>
+                    <a:bodyPr/>
+                    <a:lstStyle/>
+                    <a:p>
+                      <a:pPr algn="r"/>
+                      <a:r>
+                        <a:rPr sz="1000">
+                          <a:solidFill>
+                            <a:srgbClr val="52514E"/>
+                          </a:solidFill>
+                          <a:latin typeface="Calibri"/>
+                        </a:rPr>
+                        <a:t>0.527</a:t>
+                      </a:r>
+                    </a:p>
+                  </a:txBody>
+                  <a:tcPr marL="73152" marR="73152" marT="27432" marB="27432" anchor="ctr">
+                    <a:solidFill>
+                      <a:srgbClr val="FFFFFF"/>
+                    </a:solidFill>
+                  </a:tcPr>
+                </a:tc>
+                <a:tc>
+                  <a:txBody>
+                    <a:bodyPr/>
+                    <a:lstStyle/>
+                    <a:p>
+                      <a:pPr algn="r"/>
+                      <a:r>
+                        <a:rPr sz="1000">
+                          <a:solidFill>
+                            <a:srgbClr val="52514E"/>
+                          </a:solidFill>
+                          <a:latin typeface="Calibri"/>
+                        </a:rPr>
+                        <a:t/>
+                      </a:r>
+                    </a:p>
+                  </a:txBody>
+                  <a:tcPr marL="73152" marR="73152" marT="27432" marB="27432" anchor="ctr">
+                    <a:solidFill>
+                      <a:srgbClr val="FFFFFF"/>
+                    </a:solidFill>
+                  </a:tcPr>
+                </a:tc>
+              </a:tr>
+              <a:tr h="265176">
+                <a:tc>
+                  <a:txBody>
+                    <a:bodyPr/>
+                    <a:lstStyle/>
+                    <a:p>
+                      <a:pPr algn="l"/>
+                      <a:r>
+                        <a:rPr sz="1000" b="1">
+                          <a:solidFill>
+                            <a:srgbClr val="0B0B0B"/>
+                          </a:solidFill>
+                          <a:latin typeface="Calibri"/>
+                        </a:rPr>
+                        <a:t>D7 + D4 LOF</a:t>
+                      </a:r>
+                    </a:p>
+                  </a:txBody>
+                  <a:tcPr marL="73152" marR="73152" marT="27432" marB="27432" anchor="ctr">
+                    <a:solidFill>
+                      <a:srgbClr val="EEF4FC"/>
+                    </a:solidFill>
+                  </a:tcPr>
+                </a:tc>
+                <a:tc>
+                  <a:txBody>
+                    <a:bodyPr/>
+                    <a:lstStyle/>
+                    <a:p>
+                      <a:pPr algn="r"/>
+                      <a:r>
+                        <a:rPr sz="1000" b="1">
+                          <a:solidFill>
+                            <a:srgbClr val="0B0B0B"/>
+                          </a:solidFill>
+                          <a:latin typeface="Calibri"/>
+                        </a:rPr>
+                        <a:t>0.541</a:t>
+                      </a:r>
+                    </a:p>
+                  </a:txBody>
+                  <a:tcPr marL="73152" marR="73152" marT="27432" marB="27432" anchor="ctr">
+                    <a:solidFill>
+                      <a:srgbClr val="EEF4FC"/>
+                    </a:solidFill>
+                  </a:tcPr>
+                </a:tc>
+                <a:tc>
+                  <a:txBody>
+                    <a:bodyPr/>
+                    <a:lstStyle/>
+                    <a:p>
+                      <a:pPr algn="r"/>
+                      <a:r>
+                        <a:rPr sz="1000" b="1">
+                          <a:solidFill>
+                            <a:srgbClr val="0B0B0B"/>
+                          </a:solidFill>
+                          <a:latin typeface="Calibri"/>
+                        </a:rPr>
+                        <a:t>0.482</a:t>
+                      </a:r>
+                    </a:p>
+                  </a:txBody>
+                  <a:tcPr marL="73152" marR="73152" marT="27432" marB="27432" anchor="ctr">
+                    <a:solidFill>
+                      <a:srgbClr val="EEF4FC"/>
+                    </a:solidFill>
+                  </a:tcPr>
+                </a:tc>
+                <a:tc>
+                  <a:txBody>
+                    <a:bodyPr/>
+                    <a:lstStyle/>
+                    <a:p>
+                      <a:pPr algn="r"/>
+                      <a:r>
+                        <a:rPr sz="1000" b="1">
+                          <a:solidFill>
+                            <a:srgbClr val="0B0B0B"/>
+                          </a:solidFill>
+                          <a:latin typeface="Calibri"/>
+                        </a:rPr>
+                        <a:t>0.571</a:t>
+                      </a:r>
+                    </a:p>
+                  </a:txBody>
+                  <a:tcPr marL="73152" marR="73152" marT="27432" marB="27432" anchor="ctr">
+                    <a:solidFill>
+                      <a:srgbClr val="EEF4FC"/>
+                    </a:solidFill>
+                  </a:tcPr>
+                </a:tc>
+                <a:tc>
+                  <a:txBody>
+                    <a:bodyPr/>
+                    <a:lstStyle/>
+                    <a:p>
+                      <a:pPr algn="r"/>
+                      <a:r>
+                        <a:rPr sz="1000" b="1">
+                          <a:solidFill>
+                            <a:srgbClr val="0B0B0B"/>
+                          </a:solidFill>
+                          <a:latin typeface="Calibri"/>
+                        </a:rPr>
+                        <a:t>adopted</a:t>
+                      </a:r>
+                    </a:p>
+                  </a:txBody>
+                  <a:tcPr marL="73152" marR="73152" marT="27432" marB="27432" anchor="ctr">
+                    <a:solidFill>
+                      <a:srgbClr val="EEF4FC"/>
+                    </a:solidFill>
+                  </a:tcPr>
+                </a:tc>
+              </a:tr>
+              <a:tr h="265176">
+                <a:tc>
+                  <a:txBody>
+                    <a:bodyPr/>
+                    <a:lstStyle/>
+                    <a:p>
+                      <a:pPr algn="l"/>
+                      <a:r>
+                        <a:rPr sz="1000">
+                          <a:solidFill>
+                            <a:srgbClr val="52514E"/>
+                          </a:solidFill>
+                          <a:latin typeface="Calibri"/>
+                        </a:rPr>
+                        <a:t>D8 AR forecast</a:t>
+                      </a:r>
+                    </a:p>
+                  </a:txBody>
+                  <a:tcPr marL="73152" marR="73152" marT="27432" marB="27432" anchor="ctr">
+                    <a:solidFill>
+                      <a:srgbClr val="FFFFFF"/>
+                    </a:solidFill>
+                  </a:tcPr>
+                </a:tc>
+                <a:tc>
+                  <a:txBody>
+                    <a:bodyPr/>
+                    <a:lstStyle/>
+                    <a:p>
+                      <a:pPr algn="r"/>
+                      <a:r>
+                        <a:rPr sz="1000">
+                          <a:solidFill>
+                            <a:srgbClr val="52514E"/>
+                          </a:solidFill>
+                          <a:latin typeface="Calibri"/>
+                        </a:rPr>
+                        <a:t>0.482</a:t>
+                      </a:r>
+                    </a:p>
+                  </a:txBody>
+                  <a:tcPr marL="73152" marR="73152" marT="27432" marB="27432" anchor="ctr">
+                    <a:solidFill>
+                      <a:srgbClr val="FFFFFF"/>
+                    </a:solidFill>
+                  </a:tcPr>
+                </a:tc>
+                <a:tc>
+                  <a:txBody>
+                    <a:bodyPr/>
+                    <a:lstStyle/>
+                    <a:p>
+                      <a:pPr algn="r"/>
+                      <a:r>
+                        <a:rPr sz="1000">
+                          <a:solidFill>
+                            <a:srgbClr val="52514E"/>
+                          </a:solidFill>
+                          <a:latin typeface="Calibri"/>
+                        </a:rPr>
+                        <a:t>0.464</a:t>
+                      </a:r>
+                    </a:p>
+                  </a:txBody>
+                  <a:tcPr marL="73152" marR="73152" marT="27432" marB="27432" anchor="ctr">
+                    <a:solidFill>
+                      <a:srgbClr val="FFFFFF"/>
+                    </a:solidFill>
+                  </a:tcPr>
+                </a:tc>
+                <a:tc>
+                  <a:txBody>
+                    <a:bodyPr/>
+                    <a:lstStyle/>
+                    <a:p>
+                      <a:pPr algn="r"/>
+                      <a:r>
+                        <a:rPr sz="1000">
+                          <a:solidFill>
+                            <a:srgbClr val="52514E"/>
+                          </a:solidFill>
+                          <a:latin typeface="Calibri"/>
+                        </a:rPr>
+                        <a:t>0.541</a:t>
+                      </a:r>
+                    </a:p>
+                  </a:txBody>
+                  <a:tcPr marL="73152" marR="73152" marT="27432" marB="27432" anchor="ctr">
+                    <a:solidFill>
+                      <a:srgbClr val="FFFFFF"/>
+                    </a:solidFill>
+                  </a:tcPr>
+                </a:tc>
+                <a:tc>
+                  <a:txBody>
+                    <a:bodyPr/>
+                    <a:lstStyle/>
+                    <a:p>
+                      <a:pPr algn="r"/>
+                      <a:r>
+                        <a:rPr sz="1000">
+                          <a:solidFill>
+                            <a:srgbClr val="52514E"/>
+                          </a:solidFill>
+                          <a:latin typeface="Calibri"/>
+                        </a:rPr>
+                        <a:t>–</a:t>
+                      </a:r>
+                    </a:p>
+                  </a:txBody>
+                  <a:tcPr marL="73152" marR="73152" marT="27432" marB="27432" anchor="ctr">
+                    <a:solidFill>
+                      <a:srgbClr val="FFFFFF"/>
+                    </a:solidFill>
+                  </a:tcPr>
+                </a:tc>
+              </a:tr>
+              <a:tr h="265176">
+                <a:tc>
+                  <a:txBody>
+                    <a:bodyPr/>
+                    <a:lstStyle/>
+                    <a:p>
+                      <a:pPr algn="l"/>
+                      <a:r>
+                        <a:rPr sz="1000">
+                          <a:solidFill>
+                            <a:srgbClr val="52514E"/>
+                          </a:solidFill>
+                          <a:latin typeface="Calibri"/>
+                        </a:rPr>
+                        <a:t>D7 subspace (lag 32)</a:t>
+                      </a:r>
+                    </a:p>
+                  </a:txBody>
+                  <a:tcPr marL="73152" marR="73152" marT="27432" marB="27432" anchor="ctr">
+                    <a:solidFill>
+                      <a:srgbClr val="F7F7F5"/>
+                    </a:solidFill>
+                  </a:tcPr>
+                </a:tc>
+                <a:tc>
+                  <a:txBody>
+                    <a:bodyPr/>
+                    <a:lstStyle/>
+                    <a:p>
+                      <a:pPr algn="r"/>
+                      <a:r>
+                        <a:rPr sz="1000">
+                          <a:solidFill>
+                            <a:srgbClr val="52514E"/>
+                          </a:solidFill>
+                          <a:latin typeface="Calibri"/>
+                        </a:rPr>
+                        <a:t>0.532</a:t>
+                      </a:r>
+                    </a:p>
+                  </a:txBody>
+                  <a:tcPr marL="73152" marR="73152" marT="27432" marB="27432" anchor="ctr">
+                    <a:solidFill>
+                      <a:srgbClr val="F7F7F5"/>
+                    </a:solidFill>
+                  </a:tcPr>
+                </a:tc>
+                <a:tc>
+                  <a:txBody>
+                    <a:bodyPr/>
+                    <a:lstStyle/>
+                    <a:p>
+                      <a:pPr algn="r"/>
+                      <a:r>
+                        <a:rPr sz="1000">
+                          <a:solidFill>
+                            <a:srgbClr val="52514E"/>
+                          </a:solidFill>
+                          <a:latin typeface="Calibri"/>
+                        </a:rPr>
+                        <a:t>0.509</a:t>
+                      </a:r>
+                    </a:p>
+                  </a:txBody>
+                  <a:tcPr marL="73152" marR="73152" marT="27432" marB="27432" anchor="ctr">
+                    <a:solidFill>
+                      <a:srgbClr val="F7F7F5"/>
+                    </a:solidFill>
+                  </a:tcPr>
+                </a:tc>
+                <a:tc>
+                  <a:txBody>
+                    <a:bodyPr/>
+                    <a:lstStyle/>
+                    <a:p>
+                      <a:pPr algn="r"/>
+                      <a:r>
+                        <a:rPr sz="1000">
+                          <a:solidFill>
+                            <a:srgbClr val="52514E"/>
+                          </a:solidFill>
+                          <a:latin typeface="Calibri"/>
+                        </a:rPr>
+                        <a:t>0.538</a:t>
+                      </a:r>
+                    </a:p>
+                  </a:txBody>
+                  <a:tcPr marL="73152" marR="73152" marT="27432" marB="27432" anchor="ctr">
+                    <a:solidFill>
+                      <a:srgbClr val="F7F7F5"/>
+                    </a:solidFill>
+                  </a:tcPr>
+                </a:tc>
+                <a:tc>
+                  <a:txBody>
+                    <a:bodyPr/>
+                    <a:lstStyle/>
+                    <a:p>
+                      <a:pPr algn="r"/>
+                      <a:r>
+                        <a:rPr sz="1000">
+                          <a:solidFill>
+                            <a:srgbClr val="52514E"/>
+                          </a:solidFill>
+                          <a:latin typeface="Calibri"/>
+                        </a:rPr>
+                        <a:t>adopted</a:t>
+                      </a:r>
+                    </a:p>
+                  </a:txBody>
+                  <a:tcPr marL="73152" marR="73152" marT="27432" marB="27432" anchor="ctr">
+                    <a:solidFill>
+                      <a:srgbClr val="F7F7F5"/>
+                    </a:solidFill>
+                  </a:tcPr>
+                </a:tc>
+              </a:tr>
+              <a:tr h="265176">
+                <a:tc>
+                  <a:txBody>
+                    <a:bodyPr/>
+                    <a:lstStyle/>
+                    <a:p>
+                      <a:pPr algn="l"/>
+                      <a:r>
+                        <a:rPr sz="1000">
+                          <a:solidFill>
+                            <a:srgbClr val="52514E"/>
+                          </a:solidFill>
+                          <a:latin typeface="Calibri"/>
+                        </a:rPr>
+                        <a:t>D7 subspace, lag tuned</a:t>
+                      </a:r>
+                    </a:p>
+                  </a:txBody>
+                  <a:tcPr marL="73152" marR="73152" marT="27432" marB="27432" anchor="ctr">
+                    <a:solidFill>
+                      <a:srgbClr val="FFFFFF"/>
+                    </a:solidFill>
+                  </a:tcPr>
+                </a:tc>
+                <a:tc>
+                  <a:txBody>
+                    <a:bodyPr/>
+                    <a:lstStyle/>
+                    <a:p>
+                      <a:pPr algn="r"/>
+                      <a:r>
+                        <a:rPr sz="1000">
+                          <a:solidFill>
+                            <a:srgbClr val="52514E"/>
+                          </a:solidFill>
+                          <a:latin typeface="Calibri"/>
+                        </a:rPr>
+                        <a:t>0.533</a:t>
+                      </a:r>
+                    </a:p>
+                  </a:txBody>
+                  <a:tcPr marL="73152" marR="73152" marT="27432" marB="27432" anchor="ctr">
+                    <a:solidFill>
+                      <a:srgbClr val="FFFFFF"/>
+                    </a:solidFill>
+                  </a:tcPr>
+                </a:tc>
+                <a:tc>
+                  <a:txBody>
+                    <a:bodyPr/>
+                    <a:lstStyle/>
+                    <a:p>
+                      <a:pPr algn="r"/>
+                      <a:r>
+                        <a:rPr sz="1000">
+                          <a:solidFill>
+                            <a:srgbClr val="52514E"/>
+                          </a:solidFill>
+                          <a:latin typeface="Calibri"/>
+                        </a:rPr>
+                        <a:t>0.476</a:t>
+                      </a:r>
+                    </a:p>
+                  </a:txBody>
+                  <a:tcPr marL="73152" marR="73152" marT="27432" marB="27432" anchor="ctr">
+                    <a:solidFill>
+                      <a:srgbClr val="FFFFFF"/>
+                    </a:solidFill>
+                  </a:tcPr>
+                </a:tc>
+                <a:tc>
+                  <a:txBody>
+                    <a:bodyPr/>
+                    <a:lstStyle/>
+                    <a:p>
+                      <a:pPr algn="r"/>
+                      <a:r>
+                        <a:rPr sz="1000">
+                          <a:solidFill>
+                            <a:srgbClr val="52514E"/>
+                          </a:solidFill>
+                          <a:latin typeface="Calibri"/>
+                        </a:rPr>
+                        <a:t>0.538</a:t>
+                      </a:r>
+                    </a:p>
+                  </a:txBody>
+                  <a:tcPr marL="73152" marR="73152" marT="27432" marB="27432" anchor="ctr">
+                    <a:solidFill>
+                      <a:srgbClr val="FFFFFF"/>
+                    </a:solidFill>
+                  </a:tcPr>
+                </a:tc>
+                <a:tc>
+                  <a:txBody>
+                    <a:bodyPr/>
+                    <a:lstStyle/>
+                    <a:p>
+                      <a:pPr algn="r"/>
+                      <a:r>
+                        <a:rPr sz="1000">
+                          <a:solidFill>
+                            <a:srgbClr val="52514E"/>
+                          </a:solidFill>
+                          <a:latin typeface="Calibri"/>
+                        </a:rPr>
+                        <a:t>–</a:t>
+                      </a:r>
+                    </a:p>
+                  </a:txBody>
+                  <a:tcPr marL="73152" marR="73152" marT="27432" marB="27432" anchor="ctr">
+                    <a:solidFill>
+                      <a:srgbClr val="FFFFFF"/>
+                    </a:solidFill>
+                  </a:tcPr>
+                </a:tc>
+              </a:tr>
+              <a:tr h="265176">
+                <a:tc>
+                  <a:txBody>
+                    <a:bodyPr/>
+                    <a:lstStyle/>
+                    <a:p>
+                      <a:pPr algn="l"/>
+                      <a:r>
+                        <a:rPr sz="1000">
+                          <a:solidFill>
+                            <a:srgbClr val="52514E"/>
+                          </a:solidFill>
+                          <a:latin typeface="Calibri"/>
+                        </a:rPr>
+                        <a:t>D7 + D6 T²</a:t>
+                      </a:r>
+                    </a:p>
+                  </a:txBody>
+                  <a:tcPr marL="73152" marR="73152" marT="27432" marB="27432" anchor="ctr">
+                    <a:solidFill>
+                      <a:srgbClr val="F7F7F5"/>
+                    </a:solidFill>
+                  </a:tcPr>
+                </a:tc>
+                <a:tc>
+                  <a:txBody>
+                    <a:bodyPr/>
+                    <a:lstStyle/>
+                    <a:p>
+                      <a:pPr algn="r"/>
+                      <a:r>
+                        <a:rPr sz="1000">
+                          <a:solidFill>
+                            <a:srgbClr val="52514E"/>
+                          </a:solidFill>
+                          <a:latin typeface="Calibri"/>
+                        </a:rPr>
+                        <a:t>0.523</a:t>
+                      </a:r>
+                    </a:p>
+                  </a:txBody>
+                  <a:tcPr marL="73152" marR="73152" marT="27432" marB="27432" anchor="ctr">
+                    <a:solidFill>
+                      <a:srgbClr val="F7F7F5"/>
+                    </a:solidFill>
+                  </a:tcPr>
+                </a:tc>
+                <a:tc>
+                  <a:txBody>
+                    <a:bodyPr/>
+                    <a:lstStyle/>
+                    <a:p>
+                      <a:pPr algn="r"/>
+                      <a:r>
+                        <a:rPr sz="1000">
+                          <a:solidFill>
+                            <a:srgbClr val="52514E"/>
+                          </a:solidFill>
+                          <a:latin typeface="Calibri"/>
+                        </a:rPr>
+                        <a:t>0.496</a:t>
+                      </a:r>
+                    </a:p>
+                  </a:txBody>
+                  <a:tcPr marL="73152" marR="73152" marT="27432" marB="27432" anchor="ctr">
+                    <a:solidFill>
+                      <a:srgbClr val="F7F7F5"/>
+                    </a:solidFill>
+                  </a:tcPr>
+                </a:tc>
+                <a:tc>
+                  <a:txBody>
+                    <a:bodyPr/>
+                    <a:lstStyle/>
+                    <a:p>
+                      <a:pPr algn="r"/>
+                      <a:r>
+                        <a:rPr sz="1000">
+                          <a:solidFill>
+                            <a:srgbClr val="52514E"/>
+                          </a:solidFill>
+                          <a:latin typeface="Calibri"/>
+                        </a:rPr>
+                        <a:t>0.531</a:t>
+                      </a:r>
+                    </a:p>
+                  </a:txBody>
+                  <a:tcPr marL="73152" marR="73152" marT="27432" marB="27432" anchor="ctr">
+                    <a:solidFill>
+                      <a:srgbClr val="F7F7F5"/>
+                    </a:solidFill>
+                  </a:tcPr>
+                </a:tc>
+                <a:tc>
+                  <a:txBody>
+                    <a:bodyPr/>
+                    <a:lstStyle/>
+                    <a:p>
+                      <a:pPr algn="r"/>
+                      <a:r>
+                        <a:rPr sz="1000">
+                          <a:solidFill>
+                            <a:srgbClr val="52514E"/>
+                          </a:solidFill>
+                          <a:latin typeface="Calibri"/>
+                        </a:rPr>
+                        <a:t>adopted</a:t>
+                      </a:r>
+                    </a:p>
+                  </a:txBody>
+                  <a:tcPr marL="73152" marR="73152" marT="27432" marB="27432" anchor="ctr">
+                    <a:solidFill>
+                      <a:srgbClr val="F7F7F5"/>
+                    </a:solidFill>
+                  </a:tcPr>
+                </a:tc>
+              </a:tr>
+              <a:tr h="265176">
+                <a:tc>
+                  <a:txBody>
+                    <a:bodyPr/>
+                    <a:lstStyle/>
+                    <a:p>
+                      <a:pPr algn="l"/>
+                      <a:r>
+                        <a:rPr sz="1000">
+                          <a:solidFill>
+                            <a:srgbClr val="52514E"/>
+                          </a:solidFill>
+                          <a:latin typeface="Calibri"/>
+                        </a:rPr>
+                        <a:t>D7 + D9 neural</a:t>
+                      </a:r>
+                    </a:p>
+                  </a:txBody>
+                  <a:tcPr marL="73152" marR="73152" marT="27432" marB="27432" anchor="ctr">
+                    <a:solidFill>
+                      <a:srgbClr val="FFFFFF"/>
+                    </a:solidFill>
+                  </a:tcPr>
+                </a:tc>
+                <a:tc>
+                  <a:txBody>
+                    <a:bodyPr/>
+                    <a:lstStyle/>
+                    <a:p>
+                      <a:pPr algn="r"/>
+                      <a:r>
+                        <a:rPr sz="1000">
+                          <a:solidFill>
+                            <a:srgbClr val="52514E"/>
+                          </a:solidFill>
+                          <a:latin typeface="Calibri"/>
+                        </a:rPr>
+                        <a:t>0.530</a:t>
+                      </a:r>
+                    </a:p>
+                  </a:txBody>
+                  <a:tcPr marL="73152" marR="73152" marT="27432" marB="27432" anchor="ctr">
+                    <a:solidFill>
+                      <a:srgbClr val="FFFFFF"/>
+                    </a:solidFill>
+                  </a:tcPr>
+                </a:tc>
+                <a:tc>
+                  <a:txBody>
+                    <a:bodyPr/>
+                    <a:lstStyle/>
+                    <a:p>
+                      <a:pPr algn="r"/>
+                      <a:r>
+                        <a:rPr sz="1000">
+                          <a:solidFill>
+                            <a:srgbClr val="52514E"/>
+                          </a:solidFill>
+                          <a:latin typeface="Calibri"/>
+                        </a:rPr>
+                        <a:t>0.504</a:t>
+                      </a:r>
+                    </a:p>
+                  </a:txBody>
+                  <a:tcPr marL="73152" marR="73152" marT="27432" marB="27432" anchor="ctr">
+                    <a:solidFill>
+                      <a:srgbClr val="FFFFFF"/>
+                    </a:solidFill>
+                  </a:tcPr>
+                </a:tc>
+                <a:tc>
+                  <a:txBody>
+                    <a:bodyPr/>
+                    <a:lstStyle/>
+                    <a:p>
+                      <a:pPr algn="r"/>
+                      <a:r>
+                        <a:rPr sz="1000">
+                          <a:solidFill>
+                            <a:srgbClr val="52514E"/>
+                          </a:solidFill>
+                          <a:latin typeface="Calibri"/>
+                        </a:rPr>
+                        <a:t>0.528</a:t>
+                      </a:r>
+                    </a:p>
+                  </a:txBody>
+                  <a:tcPr marL="73152" marR="73152" marT="27432" marB="27432" anchor="ctr">
+                    <a:solidFill>
+                      <a:srgbClr val="FFFFFF"/>
+                    </a:solidFill>
+                  </a:tcPr>
+                </a:tc>
+                <a:tc>
+                  <a:txBody>
+                    <a:bodyPr/>
+                    <a:lstStyle/>
+                    <a:p>
+                      <a:pPr algn="r"/>
+                      <a:r>
+                        <a:rPr sz="1000">
+                          <a:solidFill>
+                            <a:srgbClr val="52514E"/>
+                          </a:solidFill>
+                          <a:latin typeface="Calibri"/>
+                        </a:rPr>
+                        <a:t>adopted</a:t>
+                      </a:r>
+                    </a:p>
+                  </a:txBody>
+                  <a:tcPr marL="73152" marR="73152" marT="27432" marB="27432" anchor="ctr">
+                    <a:solidFill>
+                      <a:srgbClr val="FFFFFF"/>
+                    </a:solidFill>
+                  </a:tcPr>
+                </a:tc>
+              </a:tr>
+              <a:tr h="265176">
+                <a:tc>
+                  <a:txBody>
+                    <a:bodyPr/>
+                    <a:lstStyle/>
+                    <a:p>
+                      <a:pPr algn="l"/>
+                      <a:r>
+                        <a:rPr sz="1000">
+                          <a:solidFill>
+                            <a:srgbClr val="52514E"/>
+                          </a:solidFill>
+                          <a:latin typeface="Calibri"/>
+                        </a:rPr>
+                        <a:t>D6 Hotelling T²</a:t>
+                      </a:r>
+                    </a:p>
+                  </a:txBody>
+                  <a:tcPr marL="73152" marR="73152" marT="27432" marB="27432" anchor="ctr">
+                    <a:solidFill>
+                      <a:srgbClr val="F7F7F5"/>
+                    </a:solidFill>
+                  </a:tcPr>
+                </a:tc>
+                <a:tc>
+                  <a:txBody>
+                    <a:bodyPr/>
+                    <a:lstStyle/>
+                    <a:p>
+                      <a:pPr algn="r"/>
+                      <a:r>
+                        <a:rPr sz="1000">
+                          <a:solidFill>
+                            <a:srgbClr val="52514E"/>
+                          </a:solidFill>
+                          <a:latin typeface="Calibri"/>
+                        </a:rPr>
+                        <a:t>0.541</a:t>
+                      </a:r>
+                    </a:p>
+                  </a:txBody>
+                  <a:tcPr marL="73152" marR="73152" marT="27432" marB="27432" anchor="ctr">
+                    <a:solidFill>
+                      <a:srgbClr val="F7F7F5"/>
+                    </a:solidFill>
+                  </a:tcPr>
+                </a:tc>
+                <a:tc>
+                  <a:txBody>
+                    <a:bodyPr/>
+                    <a:lstStyle/>
+                    <a:p>
+                      <a:pPr algn="r"/>
+                      <a:r>
+                        <a:rPr sz="1000">
+                          <a:solidFill>
+                            <a:srgbClr val="52514E"/>
+                          </a:solidFill>
+                          <a:latin typeface="Calibri"/>
+                        </a:rPr>
+                        <a:t>0.485</a:t>
+                      </a:r>
+                    </a:p>
+                  </a:txBody>
+                  <a:tcPr marL="73152" marR="73152" marT="27432" marB="27432" anchor="ctr">
+                    <a:solidFill>
+                      <a:srgbClr val="F7F7F5"/>
+                    </a:solidFill>
+                  </a:tcPr>
+                </a:tc>
+                <a:tc>
+                  <a:txBody>
+                    <a:bodyPr/>
+                    <a:lstStyle/>
+                    <a:p>
+                      <a:pPr algn="r"/>
+                      <a:r>
+                        <a:rPr sz="1000">
+                          <a:solidFill>
+                            <a:srgbClr val="52514E"/>
+                          </a:solidFill>
+                          <a:latin typeface="Calibri"/>
+                        </a:rPr>
+                        <a:t>0.527</a:t>
+                      </a:r>
+                    </a:p>
+                  </a:txBody>
+                  <a:tcPr marL="73152" marR="73152" marT="27432" marB="27432" anchor="ctr">
+                    <a:solidFill>
+                      <a:srgbClr val="F7F7F5"/>
+                    </a:solidFill>
+                  </a:tcPr>
+                </a:tc>
+                <a:tc>
+                  <a:txBody>
+                    <a:bodyPr/>
+                    <a:lstStyle/>
+                    <a:p>
+                      <a:pPr algn="r"/>
+                      <a:r>
+                        <a:rPr sz="1000">
+                          <a:solidFill>
+                            <a:srgbClr val="52514E"/>
+                          </a:solidFill>
+                          <a:latin typeface="Calibri"/>
+                        </a:rPr>
+                        <a:t>–</a:t>
+                      </a:r>
+                    </a:p>
+                  </a:txBody>
+                  <a:tcPr marL="73152" marR="73152" marT="27432" marB="27432" anchor="ctr">
+                    <a:solidFill>
+                      <a:srgbClr val="F7F7F5"/>
+                    </a:solidFill>
+                  </a:tcPr>
+                </a:tc>
+              </a:tr>
+            </a:tbl>
+          </a:graphicData>
+        </a:graphic>
+      </p:graphicFrame>
+      <p:graphicFrame>
+        <p:nvGraphicFramePr>
+          <p:cNvPr id="6" name="Chart 5"/>
+          <p:cNvGraphicFramePr>
+            <a:graphicFrameLocks noGrp="1"/>
+          </p:cNvGraphicFramePr>
+          <p:nvPr/>
+        </p:nvGraphicFramePr>
+        <p:xfrm>
+          <a:off x="6400800" y="1417320"/>
+          <a:ext cx="5257800" cy="3931920"/>
         </p:xfrm>
         <a:graphic>
           <a:graphicData uri="http://schemas.openxmlformats.org/drawingml/2006/chart">
@@ -10513,14 +11662,14 @@
       </p:graphicFrame>
       <p:sp>
         <p:nvSpPr>
-          <p:cNvPr id="6" name="TextBox 5"/>
+          <p:cNvPr id="7" name="TextBox 6"/>
           <p:cNvSpPr txBox="1"/>
           <p:nvPr/>
         </p:nvSpPr>
         <p:spPr>
           <a:xfrm>
-            <a:off x="6537960" y="5029200"/>
-            <a:ext cx="5120640" cy="320040"/>
+            <a:off x="6400800" y="5349240"/>
+            <a:ext cx="5257800" cy="548640"/>
           </a:xfrm>
           <a:prstGeom prst="rect">
             <a:avLst/>
@@ -10541,255 +11690,7 @@
                 </a:solidFill>
                 <a:latin typeface="Calibri"/>
               </a:rPr>
-              <a:t>Ablation: trigger-based event F1 (ET), each variant with its own best θ_enter</a:t>
-            </a:r>
-          </a:p>
-        </p:txBody>
-      </p:sp>
-      <p:sp>
-        <p:nvSpPr>
-          <p:cNvPr id="7" name="TextBox 6"/>
-          <p:cNvSpPr txBox="1"/>
-          <p:nvPr/>
-        </p:nvSpPr>
-        <p:spPr>
-          <a:xfrm>
-            <a:off x="548640" y="4434840"/>
-            <a:ext cx="5760720" cy="1920240"/>
-          </a:xfrm>
-          <a:prstGeom prst="rect">
-            <a:avLst/>
-          </a:prstGeom>
-          <a:noFill/>
-        </p:spPr>
-        <p:txBody>
-          <a:bodyPr wrap="square" anchor="t" lIns="0" rIns="0" tIns="0" bIns="0">
-            <a:spAutoFit/>
-          </a:bodyPr>
-          <a:lstStyle/>
-          <a:p>
-            <a:pPr algn="l">
-              <a:spcAft>
-                <a:spcPts val="100"/>
-              </a:spcAft>
-            </a:pPr>
-            <a:r>
-              <a:rPr sz="1100" b="1" i="0">
-                <a:solidFill>
-                  <a:srgbClr val="52514E"/>
-                </a:solidFill>
-                <a:latin typeface="Calibri"/>
-              </a:rPr>
-              <a:t>S1 </a:t>
-            </a:r>
-            <a:r>
-              <a:rPr sz="1100" b="0" i="0">
-                <a:solidFill>
-                  <a:srgbClr val="52514E"/>
-                </a:solidFill>
-                <a:latin typeface="Calibri"/>
-              </a:rPr>
-              <a:t>detector params (108): ET F1 0.419</a:t>
-            </a:r>
-          </a:p>
-          <a:p>
-            <a:pPr algn="l">
-              <a:spcAft>
-                <a:spcPts val="100"/>
-              </a:spcAft>
-            </a:pPr>
-            <a:r>
-              <a:rPr sz="1100" b="1" i="0">
-                <a:solidFill>
-                  <a:srgbClr val="52514E"/>
-                </a:solidFill>
-                <a:latin typeface="Calibri"/>
-              </a:rPr>
-              <a:t>S2a </a:t>
-            </a:r>
-            <a:r>
-              <a:rPr sz="1100" b="0" i="0">
-                <a:solidFill>
-                  <a:srgbClr val="52514E"/>
-                </a:solidFill>
-                <a:latin typeface="Calibri"/>
-              </a:rPr>
-              <a:t>θ, hysteresis, smoothing (36): ET F1 0.452</a:t>
-            </a:r>
-          </a:p>
-          <a:p>
-            <a:pPr algn="l">
-              <a:spcAft>
-                <a:spcPts val="100"/>
-              </a:spcAft>
-            </a:pPr>
-            <a:r>
-              <a:rPr sz="1100" b="1" i="0">
-                <a:solidFill>
-                  <a:srgbClr val="52514E"/>
-                </a:solidFill>
-                <a:latin typeface="Calibri"/>
-              </a:rPr>
-              <a:t>S2b </a:t>
-            </a:r>
-            <a:r>
-              <a:rPr sz="1100" b="0" i="0">
-                <a:solidFill>
-                  <a:srgbClr val="52514E"/>
-                </a:solidFill>
-                <a:latin typeface="Calibri"/>
-              </a:rPr>
-              <a:t>cooldown, max length (36): ET F1 0.464</a:t>
-            </a:r>
-          </a:p>
-          <a:p>
-            <a:pPr algn="l">
-              <a:spcAft>
-                <a:spcPts val="100"/>
-              </a:spcAft>
-            </a:pPr>
-            <a:r>
-              <a:rPr sz="1100" b="1" i="0">
-                <a:solidFill>
-                  <a:srgbClr val="52514E"/>
-                </a:solidFill>
-                <a:latin typeface="Calibri"/>
-              </a:rPr>
-              <a:t>S3a </a:t>
-            </a:r>
-            <a:r>
-              <a:rPr sz="1100" b="0" i="0">
-                <a:solidFill>
-                  <a:srgbClr val="52514E"/>
-                </a:solidFill>
-                <a:latin typeface="Calibri"/>
-              </a:rPr>
-              <a:t>Fisher, peak-or-mean, learn in cooldown (24): ET F1 0.470</a:t>
-            </a:r>
-          </a:p>
-          <a:p>
-            <a:pPr algn="l">
-              <a:spcAft>
-                <a:spcPts val="100"/>
-              </a:spcAft>
-            </a:pPr>
-            <a:r>
-              <a:rPr sz="1100" b="1" i="0">
-                <a:solidFill>
-                  <a:srgbClr val="52514E"/>
-                </a:solidFill>
-                <a:latin typeface="Calibri"/>
-              </a:rPr>
-              <a:t>S3b </a:t>
-            </a:r>
-            <a:r>
-              <a:rPr sz="1100" b="0" i="0">
-                <a:solidFill>
-                  <a:srgbClr val="52514E"/>
-                </a:solidFill>
-                <a:latin typeface="Calibri"/>
-              </a:rPr>
-              <a:t>season ACF, log1p (18): no gain, kept</a:t>
-            </a:r>
-          </a:p>
-          <a:p>
-            <a:pPr algn="l">
-              <a:spcAft>
-                <a:spcPts val="100"/>
-              </a:spcAft>
-            </a:pPr>
-            <a:r>
-              <a:rPr sz="1100" b="1" i="0">
-                <a:solidFill>
-                  <a:srgbClr val="52514E"/>
-                </a:solidFill>
-                <a:latin typeface="Calibri"/>
-              </a:rPr>
-              <a:t>S3c </a:t>
-            </a:r>
-            <a:r>
-              <a:rPr sz="1100" b="0" i="0">
-                <a:solidFill>
-                  <a:srgbClr val="52514E"/>
-                </a:solidFill>
-                <a:latin typeface="Calibri"/>
-              </a:rPr>
-              <a:t>capped CUSUM (9): no gain, kept</a:t>
-            </a:r>
-          </a:p>
-          <a:p>
-            <a:pPr algn="l">
-              <a:spcAft>
-                <a:spcPts val="100"/>
-              </a:spcAft>
-            </a:pPr>
-            <a:r>
-              <a:rPr sz="1100" b="1" i="0">
-                <a:solidFill>
-                  <a:srgbClr val="52514E"/>
-                </a:solidFill>
-                <a:latin typeface="Calibri"/>
-              </a:rPr>
-              <a:t>S3d </a:t>
-            </a:r>
-            <a:r>
-              <a:rPr sz="1100" b="0" i="0">
-                <a:solidFill>
-                  <a:srgbClr val="52514E"/>
-                </a:solidFill>
-                <a:latin typeface="Calibri"/>
-              </a:rPr>
-              <a:t>shape detector off (6): ET F1 0.488</a:t>
-            </a:r>
-          </a:p>
-          <a:p>
-            <a:pPr algn="l">
-              <a:spcAft>
-                <a:spcPts val="100"/>
-              </a:spcAft>
-            </a:pPr>
-            <a:r>
-              <a:rPr sz="1100" b="1" i="0">
-                <a:solidFill>
-                  <a:srgbClr val="52514E"/>
-                </a:solidFill>
-                <a:latin typeface="Calibri"/>
-              </a:rPr>
-              <a:t>S3e </a:t>
-            </a:r>
-            <a:r>
-              <a:rPr sz="1100" b="0" i="0">
-                <a:solidFill>
-                  <a:srgbClr val="52514E"/>
-                </a:solidFill>
-                <a:latin typeface="Calibri"/>
-              </a:rPr>
-              <a:t>deseasonalized CUSUM (3): no gain, kept</a:t>
-            </a:r>
-          </a:p>
-          <a:p>
-            <a:pPr algn="l">
-              <a:spcAft>
-                <a:spcPts val="100"/>
-              </a:spcAft>
-            </a:pPr>
-            <a:r>
-              <a:rPr sz="1100" b="1" i="0">
-                <a:solidFill>
-                  <a:srgbClr val="52514E"/>
-                </a:solidFill>
-                <a:latin typeface="Calibri"/>
-              </a:rPr>
-              <a:t>Final </a:t>
-            </a:r>
-            <a:r>
-              <a:rPr sz="1100" b="0" i="0">
-                <a:solidFill>
-                  <a:srgbClr val="52514E"/>
-                </a:solidFill>
-                <a:latin typeface="Calibri"/>
-              </a:rPr>
-              <a:t>ET F1 0.479 (stability rule); ET F1, held-out (nested LOCO, partial: 3 of 7 categories): 0.381</a:t>
+              <a:t>Ablation of the final system: trigger-based event F1 (ET), each variant with its own best θ_enter (results/ablation.csv)</a:t>
             </a:r>
           </a:p>
         </p:txBody>
@@ -11528,7 +12429,7 @@
                 </a:solidFill>
                 <a:latin typeface="Calibri"/>
               </a:rPr>
-              <a:t>Nested leave-one-category-out (LOCO)</a:t>
+              <a:t>Two held-out checks: categories and time</a:t>
             </a:r>
           </a:p>
         </p:txBody>
@@ -11948,7 +12849,7 @@
                 </a:solidFill>
                 <a:latin typeface="Calibri"/>
               </a:rPr>
-              <a:t>The whole staged search runs on 6 categories; its pick is scored on the 7th. Run for 3 of 7 categories (cost); one global config, no per-file tuning.</a:t>
+              <a:t>θ-LOCO: θ chosen on 6 categories, scored on the 7th. Time split: θ chosen on the early half of every file, scored on the late half. One global config.</a:t>
             </a:r>
           </a:p>
         </p:txBody>
@@ -12001,7 +12902,7 @@
                 </a:solidFill>
                 <a:latin typeface="Calibri"/>
               </a:rPr>
-              <a:t>Sentinel trigger-based event F1 per category (windows found / windows), final config on all files. On the 5 no-anomaly files: 1 false alert.</a:t>
+              <a:t>Sentinel trigger-based event F1 per category (windows found / windows), final config on all files. On the 5 no-anomaly files: 0 false alerts.</a:t>
             </a:r>
           </a:p>
         </p:txBody>
@@ -12205,7 +13106,7 @@
                 </a:solidFill>
                 <a:latin typeface="Calibri"/>
               </a:rPr>
-              <a:t>0.48</a:t>
+              <a:t>0.54</a:t>
             </a:r>
           </a:p>
         </p:txBody>
@@ -12240,7 +13141,7 @@
                 </a:solidFill>
                 <a:latin typeface="Calibri"/>
               </a:rPr>
-              <a:t>ET F1, all files (95% CI 0.38–0.56)</a:t>
+              <a:t>ET F1, all files (95% CI 0.45–0.64)</a:t>
             </a:r>
           </a:p>
         </p:txBody>
@@ -12321,7 +13222,7 @@
                 </a:solidFill>
                 <a:latin typeface="Calibri"/>
               </a:rPr>
-              <a:t>0.38</a:t>
+              <a:t>0.48</a:t>
             </a:r>
           </a:p>
         </p:txBody>
@@ -12356,7 +13257,7 @@
                 </a:solidFill>
                 <a:latin typeface="Calibri"/>
               </a:rPr>
-              <a:t>ET F1, held-out (nested LOCO, partial: 3 of 7 categories)</a:t>
+              <a:t>held-out categories (θ-LOCO); late halves 0.57</a:t>
             </a:r>
           </a:p>
         </p:txBody>
@@ -12437,7 +13338,7 @@
                 </a:solidFill>
                 <a:latin typeface="Calibri"/>
               </a:rPr>
-              <a:t>0.51 / 0.45</a:t>
+              <a:t>0.62 / 0.48</a:t>
             </a:r>
           </a:p>
         </p:txBody>
@@ -12472,7 +13373,7 @@
                 </a:solidFill>
                 <a:latin typeface="Calibri"/>
               </a:rPr>
-              <a:t>precision / recall (52/116 windows, 49 false)</a:t>
+              <a:t>precision / recall (56/116 windows, 35 false)</a:t>
             </a:r>
           </a:p>
         </p:txBody>
@@ -12553,7 +13454,7 @@
                 </a:solidFill>
                 <a:latin typeface="Calibri"/>
               </a:rPr>
-              <a:t>23 µs</a:t>
+              <a:t>20.9 µs</a:t>
             </a:r>
           </a:p>
         </p:txBody>
@@ -12588,7 +13489,7 @@
                 </a:solidFill>
                 <a:latin typeface="Calibri"/>
               </a:rPr>
-              <a:t>per point, one CPU core</a:t>
+              <a:t>per point, compiled engine (181 µs streaming API)</a:t>
             </a:r>
           </a:p>
         </p:txBody>
@@ -12603,7 +13504,7 @@
         </p:nvGraphicFramePr>
         <p:xfrm>
           <a:off x="548640" y="2697480"/>
-          <a:ext cx="11064239" cy="2560320"/>
+          <a:ext cx="11064239" cy="2633472"/>
         </p:xfrm>
         <a:graphic>
           <a:graphicData uri="http://schemas.openxmlformats.org/drawingml/2006/table">
@@ -12621,7 +13522,7 @@
                 <a:gridCol w="914400"/>
                 <a:gridCol w="1280160"/>
               </a:tblGrid>
-              <a:tr h="365760">
+              <a:tr h="329184">
                 <a:tc>
                   <a:txBody>
                     <a:bodyPr/>
@@ -12629,7 +13530,7 @@
                     <a:p>
                       <a:pPr algn="l"/>
                       <a:r>
-                        <a:rPr sz="1200" b="1">
+                        <a:rPr sz="1100" b="1">
                           <a:solidFill>
                             <a:srgbClr val="FFFFFF"/>
                           </a:solidFill>
@@ -12652,7 +13553,7 @@
                     <a:p>
                       <a:pPr algn="r"/>
                       <a:r>
-                        <a:rPr sz="1200" b="1">
+                        <a:rPr sz="1100" b="1">
                           <a:solidFill>
                             <a:srgbClr val="FFFFFF"/>
                           </a:solidFill>
@@ -12675,7 +13576,7 @@
                     <a:p>
                       <a:pPr algn="r"/>
                       <a:r>
-                        <a:rPr sz="1200" b="1">
+                        <a:rPr sz="1100" b="1">
                           <a:solidFill>
                             <a:srgbClr val="FFFFFF"/>
                           </a:solidFill>
@@ -12698,7 +13599,7 @@
                     <a:p>
                       <a:pPr algn="r"/>
                       <a:r>
-                        <a:rPr sz="1200" b="1">
+                        <a:rPr sz="1100" b="1">
                           <a:solidFill>
                             <a:srgbClr val="FFFFFF"/>
                           </a:solidFill>
@@ -12721,7 +13622,7 @@
                     <a:p>
                       <a:pPr algn="r"/>
                       <a:r>
-                        <a:rPr sz="1200" b="1">
+                        <a:rPr sz="1100" b="1">
                           <a:solidFill>
                             <a:srgbClr val="FFFFFF"/>
                           </a:solidFill>
@@ -12744,7 +13645,7 @@
                     <a:p>
                       <a:pPr algn="r"/>
                       <a:r>
-                        <a:rPr sz="1200" b="1">
+                        <a:rPr sz="1100" b="1">
                           <a:solidFill>
                             <a:srgbClr val="FFFFFF"/>
                           </a:solidFill>
@@ -12767,7 +13668,7 @@
                     <a:p>
                       <a:pPr algn="r"/>
                       <a:r>
-                        <a:rPr sz="1200" b="1">
+                        <a:rPr sz="1100" b="1">
                           <a:solidFill>
                             <a:srgbClr val="FFFFFF"/>
                           </a:solidFill>
@@ -12790,7 +13691,7 @@
                     <a:p>
                       <a:pPr algn="r"/>
                       <a:r>
-                        <a:rPr sz="1200" b="1">
+                        <a:rPr sz="1100" b="1">
                           <a:solidFill>
                             <a:srgbClr val="FFFFFF"/>
                           </a:solidFill>
@@ -12807,7 +13708,7 @@
                   </a:tcPr>
                 </a:tc>
               </a:tr>
-              <a:tr h="365760">
+              <a:tr h="329184">
                 <a:tc>
                   <a:txBody>
                     <a:bodyPr/>
@@ -12815,13 +13716,13 @@
                     <a:p>
                       <a:pPr algn="l"/>
                       <a:r>
-                        <a:rPr sz="1200" b="1">
+                        <a:rPr sz="1100" b="1">
                           <a:solidFill>
                             <a:srgbClr val="0B0B0B"/>
                           </a:solidFill>
                           <a:latin typeface="Calibri"/>
                         </a:rPr>
-                        <a:t>Sentinel</a:t>
+                        <a:t>Sentinel v3 (D1 + D2 + D4 + D7)</a:t>
                       </a:r>
                     </a:p>
                   </a:txBody>
@@ -12838,13 +13739,13 @@
                     <a:p>
                       <a:pPr algn="r"/>
                       <a:r>
-                        <a:rPr sz="1200" b="1">
+                        <a:rPr sz="1100" b="1">
                           <a:solidFill>
                             <a:srgbClr val="0B0B0B"/>
                           </a:solidFill>
                           <a:latin typeface="Calibri"/>
                         </a:rPr>
-                        <a:t>0.479</a:t>
+                        <a:t>0.541</a:t>
                       </a:r>
                     </a:p>
                   </a:txBody>
@@ -12861,13 +13762,13 @@
                     <a:p>
                       <a:pPr algn="r"/>
                       <a:r>
-                        <a:rPr sz="1200" b="1">
+                        <a:rPr sz="1100" b="1">
                           <a:solidFill>
                             <a:srgbClr val="0B0B0B"/>
                           </a:solidFill>
                           <a:latin typeface="Calibri"/>
                         </a:rPr>
-                        <a:t>0.479</a:t>
+                        <a:t>0.482</a:t>
                       </a:r>
                     </a:p>
                   </a:txBody>
@@ -12884,13 +13785,13 @@
                     <a:p>
                       <a:pPr algn="r"/>
                       <a:r>
-                        <a:rPr sz="1200" b="1">
+                        <a:rPr sz="1100" b="1">
                           <a:solidFill>
                             <a:srgbClr val="0B0B0B"/>
                           </a:solidFill>
                           <a:latin typeface="Calibri"/>
                         </a:rPr>
-                        <a:t>0.515</a:t>
+                        <a:t>0.615</a:t>
                       </a:r>
                     </a:p>
                   </a:txBody>
@@ -12907,13 +13808,13 @@
                     <a:p>
                       <a:pPr algn="r"/>
                       <a:r>
-                        <a:rPr sz="1200" b="1">
+                        <a:rPr sz="1100" b="1">
                           <a:solidFill>
                             <a:srgbClr val="0B0B0B"/>
                           </a:solidFill>
                           <a:latin typeface="Calibri"/>
                         </a:rPr>
-                        <a:t>0.448</a:t>
+                        <a:t>0.483</a:t>
                       </a:r>
                     </a:p>
                   </a:txBody>
@@ -12930,13 +13831,13 @@
                     <a:p>
                       <a:pPr algn="r"/>
                       <a:r>
-                        <a:rPr sz="1200" b="1">
+                        <a:rPr sz="1100" b="1">
                           <a:solidFill>
                             <a:srgbClr val="0B0B0B"/>
                           </a:solidFill>
                           <a:latin typeface="Calibri"/>
                         </a:rPr>
-                        <a:t>49</a:t>
+                        <a:t>35</a:t>
                       </a:r>
                     </a:p>
                   </a:txBody>
@@ -12953,13 +13854,13 @@
                     <a:p>
                       <a:pPr algn="r"/>
                       <a:r>
-                        <a:rPr sz="1200" b="1">
+                        <a:rPr sz="1100" b="1">
                           <a:solidFill>
                             <a:srgbClr val="0B0B0B"/>
                           </a:solidFill>
                           <a:latin typeface="Calibri"/>
                         </a:rPr>
-                        <a:t>0.479</a:t>
+                        <a:t>0.541</a:t>
                       </a:r>
                     </a:p>
                   </a:txBody>
@@ -12976,13 +13877,13 @@
                     <a:p>
                       <a:pPr algn="r"/>
                       <a:r>
-                        <a:rPr sz="1200" b="1">
+                        <a:rPr sz="1100" b="1">
                           <a:solidFill>
                             <a:srgbClr val="0B0B0B"/>
                           </a:solidFill>
                           <a:latin typeface="Calibri"/>
                         </a:rPr>
-                        <a:t>38.8</a:t>
+                        <a:t>42.0</a:t>
                       </a:r>
                     </a:p>
                   </a:txBody>
@@ -12993,7 +13894,7 @@
                   </a:tcPr>
                 </a:tc>
               </a:tr>
-              <a:tr h="365760">
+              <a:tr h="329184">
                 <a:tc>
                   <a:txBody>
                     <a:bodyPr/>
@@ -13001,13 +13902,13 @@
                     <a:p>
                       <a:pPr algn="l"/>
                       <a:r>
-                        <a:rPr sz="1200">
+                        <a:rPr sz="1100">
                           <a:solidFill>
                             <a:srgbClr val="52514E"/>
                           </a:solidFill>
                           <a:latin typeface="Calibri"/>
                         </a:rPr>
-                        <a:t>LOF (+ our calibration &amp; event logic)</a:t>
+                        <a:t>Sentinel v2 (D1 + D2, previous)</a:t>
                       </a:r>
                     </a:p>
                   </a:txBody>
@@ -13024,13 +13925,13 @@
                     <a:p>
                       <a:pPr algn="r"/>
                       <a:r>
-                        <a:rPr sz="1200">
+                        <a:rPr sz="1100">
                           <a:solidFill>
                             <a:srgbClr val="52514E"/>
                           </a:solidFill>
                           <a:latin typeface="Calibri"/>
                         </a:rPr>
-                        <a:t>0.467</a:t>
+                        <a:t>0.479</a:t>
                       </a:r>
                     </a:p>
                   </a:txBody>
@@ -13047,13 +13948,13 @@
                     <a:p>
                       <a:pPr algn="r"/>
                       <a:r>
-                        <a:rPr sz="1200">
+                        <a:rPr sz="1100">
                           <a:solidFill>
                             <a:srgbClr val="52514E"/>
                           </a:solidFill>
                           <a:latin typeface="Calibri"/>
                         </a:rPr>
-                        <a:t>0.467</a:t>
+                        <a:t>0.479</a:t>
                       </a:r>
                     </a:p>
                   </a:txBody>
@@ -13070,13 +13971,13 @@
                     <a:p>
                       <a:pPr algn="r"/>
                       <a:r>
-                        <a:rPr sz="1200">
+                        <a:rPr sz="1100">
                           <a:solidFill>
                             <a:srgbClr val="52514E"/>
                           </a:solidFill>
                           <a:latin typeface="Calibri"/>
                         </a:rPr>
-                        <a:t>0.510</a:t>
+                        <a:t>0.515</a:t>
                       </a:r>
                     </a:p>
                   </a:txBody>
@@ -13093,13 +13994,13 @@
                     <a:p>
                       <a:pPr algn="r"/>
                       <a:r>
-                        <a:rPr sz="1200">
+                        <a:rPr sz="1100">
                           <a:solidFill>
                             <a:srgbClr val="52514E"/>
                           </a:solidFill>
                           <a:latin typeface="Calibri"/>
                         </a:rPr>
-                        <a:t>0.431</a:t>
+                        <a:t>0.448</a:t>
                       </a:r>
                     </a:p>
                   </a:txBody>
@@ -13116,13 +14017,13 @@
                     <a:p>
                       <a:pPr algn="r"/>
                       <a:r>
-                        <a:rPr sz="1200">
+                        <a:rPr sz="1100">
                           <a:solidFill>
                             <a:srgbClr val="52514E"/>
                           </a:solidFill>
                           <a:latin typeface="Calibri"/>
                         </a:rPr>
-                        <a:t>48</a:t>
+                        <a:t>49</a:t>
                       </a:r>
                     </a:p>
                   </a:txBody>
@@ -13139,13 +14040,13 @@
                     <a:p>
                       <a:pPr algn="r"/>
                       <a:r>
-                        <a:rPr sz="1200">
+                        <a:rPr sz="1100">
                           <a:solidFill>
                             <a:srgbClr val="52514E"/>
                           </a:solidFill>
                           <a:latin typeface="Calibri"/>
                         </a:rPr>
-                        <a:t>0.467</a:t>
+                        <a:t>0.479</a:t>
                       </a:r>
                     </a:p>
                   </a:txBody>
@@ -13162,13 +14063,13 @@
                     <a:p>
                       <a:pPr algn="r"/>
                       <a:r>
-                        <a:rPr sz="1200">
+                        <a:rPr sz="1100">
                           <a:solidFill>
                             <a:srgbClr val="52514E"/>
                           </a:solidFill>
                           <a:latin typeface="Calibri"/>
                         </a:rPr>
-                        <a:t>36.7</a:t>
+                        <a:t>38.8</a:t>
                       </a:r>
                     </a:p>
                   </a:txBody>
@@ -13179,7 +14080,7 @@
                   </a:tcPr>
                 </a:tc>
               </a:tr>
-              <a:tr h="365760">
+              <a:tr h="329184">
                 <a:tc>
                   <a:txBody>
                     <a:bodyPr/>
@@ -13187,13 +14088,13 @@
                     <a:p>
                       <a:pPr algn="l"/>
                       <a:r>
-                        <a:rPr sz="1200">
+                        <a:rPr sz="1100">
                           <a:solidFill>
                             <a:srgbClr val="52514E"/>
                           </a:solidFill>
                           <a:latin typeface="Calibri"/>
                         </a:rPr>
-                        <a:t>Isolation Forest (+ our calibration &amp; event logic)</a:t>
+                        <a:t>LOF (+ our calibration &amp; event logic)</a:t>
                       </a:r>
                     </a:p>
                   </a:txBody>
@@ -13210,13 +14111,13 @@
                     <a:p>
                       <a:pPr algn="r"/>
                       <a:r>
-                        <a:rPr sz="1200">
+                        <a:rPr sz="1100">
                           <a:solidFill>
                             <a:srgbClr val="52514E"/>
                           </a:solidFill>
                           <a:latin typeface="Calibri"/>
                         </a:rPr>
-                        <a:t>0.383</a:t>
+                        <a:t>0.467</a:t>
                       </a:r>
                     </a:p>
                   </a:txBody>
@@ -13233,13 +14134,13 @@
                     <a:p>
                       <a:pPr algn="r"/>
                       <a:r>
-                        <a:rPr sz="1200">
+                        <a:rPr sz="1100">
                           <a:solidFill>
                             <a:srgbClr val="52514E"/>
                           </a:solidFill>
                           <a:latin typeface="Calibri"/>
                         </a:rPr>
-                        <a:t>0.353</a:t>
+                        <a:t>0.467</a:t>
                       </a:r>
                     </a:p>
                   </a:txBody>
@@ -13256,13 +14157,13 @@
                     <a:p>
                       <a:pPr algn="r"/>
                       <a:r>
-                        <a:rPr sz="1200">
+                        <a:rPr sz="1100">
                           <a:solidFill>
                             <a:srgbClr val="52514E"/>
                           </a:solidFill>
                           <a:latin typeface="Calibri"/>
                         </a:rPr>
-                        <a:t>0.288</a:t>
+                        <a:t>0.510</a:t>
                       </a:r>
                     </a:p>
                   </a:txBody>
@@ -13279,13 +14180,13 @@
                     <a:p>
                       <a:pPr algn="r"/>
                       <a:r>
-                        <a:rPr sz="1200">
+                        <a:rPr sz="1100">
                           <a:solidFill>
                             <a:srgbClr val="52514E"/>
                           </a:solidFill>
                           <a:latin typeface="Calibri"/>
                         </a:rPr>
-                        <a:t>0.569</a:t>
+                        <a:t>0.431</a:t>
                       </a:r>
                     </a:p>
                   </a:txBody>
@@ -13302,13 +14203,13 @@
                     <a:p>
                       <a:pPr algn="r"/>
                       <a:r>
-                        <a:rPr sz="1200">
+                        <a:rPr sz="1100">
                           <a:solidFill>
                             <a:srgbClr val="52514E"/>
                           </a:solidFill>
                           <a:latin typeface="Calibri"/>
                         </a:rPr>
-                        <a:t>163</a:t>
+                        <a:t>48</a:t>
                       </a:r>
                     </a:p>
                   </a:txBody>
@@ -13325,13 +14226,13 @@
                     <a:p>
                       <a:pPr algn="r"/>
                       <a:r>
-                        <a:rPr sz="1200">
+                        <a:rPr sz="1100">
                           <a:solidFill>
                             <a:srgbClr val="52514E"/>
                           </a:solidFill>
                           <a:latin typeface="Calibri"/>
                         </a:rPr>
-                        <a:t>0.385</a:t>
+                        <a:t>0.467</a:t>
                       </a:r>
                     </a:p>
                   </a:txBody>
@@ -13348,13 +14249,13 @@
                     <a:p>
                       <a:pPr algn="r"/>
                       <a:r>
-                        <a:rPr sz="1200">
+                        <a:rPr sz="1100">
                           <a:solidFill>
                             <a:srgbClr val="52514E"/>
                           </a:solidFill>
                           <a:latin typeface="Calibri"/>
                         </a:rPr>
-                        <a:t>44.4</a:t>
+                        <a:t>36.7</a:t>
                       </a:r>
                     </a:p>
                   </a:txBody>
@@ -13365,7 +14266,7 @@
                   </a:tcPr>
                 </a:tc>
               </a:tr>
-              <a:tr h="365760">
+              <a:tr h="329184">
                 <a:tc>
                   <a:txBody>
                     <a:bodyPr/>
@@ -13373,13 +14274,13 @@
                     <a:p>
                       <a:pPr algn="l"/>
                       <a:r>
-                        <a:rPr sz="1200">
+                        <a:rPr sz="1100">
                           <a:solidFill>
                             <a:srgbClr val="52514E"/>
                           </a:solidFill>
                           <a:latin typeface="Calibri"/>
                         </a:rPr>
-                        <a:t>Rolling z-score (+ our calibration &amp; event logic)</a:t>
+                        <a:t>Isolation Forest (+ our calibration &amp; event logic)</a:t>
                       </a:r>
                     </a:p>
                   </a:txBody>
@@ -13396,13 +14297,13 @@
                     <a:p>
                       <a:pPr algn="r"/>
                       <a:r>
-                        <a:rPr sz="1200">
+                        <a:rPr sz="1100">
                           <a:solidFill>
                             <a:srgbClr val="52514E"/>
                           </a:solidFill>
                           <a:latin typeface="Calibri"/>
                         </a:rPr>
-                        <a:t>0.332</a:t>
+                        <a:t>0.383</a:t>
                       </a:r>
                     </a:p>
                   </a:txBody>
@@ -13419,13 +14320,13 @@
                     <a:p>
                       <a:pPr algn="r"/>
                       <a:r>
-                        <a:rPr sz="1200">
+                        <a:rPr sz="1100">
                           <a:solidFill>
                             <a:srgbClr val="52514E"/>
                           </a:solidFill>
                           <a:latin typeface="Calibri"/>
                         </a:rPr>
-                        <a:t>0.332</a:t>
+                        <a:t>0.353</a:t>
                       </a:r>
                     </a:p>
                   </a:txBody>
@@ -13442,13 +14343,13 @@
                     <a:p>
                       <a:pPr algn="r"/>
                       <a:r>
-                        <a:rPr sz="1200">
+                        <a:rPr sz="1100">
                           <a:solidFill>
                             <a:srgbClr val="52514E"/>
                           </a:solidFill>
                           <a:latin typeface="Calibri"/>
                         </a:rPr>
-                        <a:t>0.295</a:t>
+                        <a:t>0.288</a:t>
                       </a:r>
                     </a:p>
                   </a:txBody>
@@ -13465,13 +14366,13 @@
                     <a:p>
                       <a:pPr algn="r"/>
                       <a:r>
-                        <a:rPr sz="1200">
+                        <a:rPr sz="1100">
                           <a:solidFill>
                             <a:srgbClr val="52514E"/>
                           </a:solidFill>
                           <a:latin typeface="Calibri"/>
                         </a:rPr>
-                        <a:t>0.379</a:t>
+                        <a:t>0.569</a:t>
                       </a:r>
                     </a:p>
                   </a:txBody>
@@ -13488,13 +14389,13 @@
                     <a:p>
                       <a:pPr algn="r"/>
                       <a:r>
-                        <a:rPr sz="1200">
+                        <a:rPr sz="1100">
                           <a:solidFill>
                             <a:srgbClr val="52514E"/>
                           </a:solidFill>
                           <a:latin typeface="Calibri"/>
                         </a:rPr>
-                        <a:t>105</a:t>
+                        <a:t>163</a:t>
                       </a:r>
                     </a:p>
                   </a:txBody>
@@ -13511,13 +14412,13 @@
                     <a:p>
                       <a:pPr algn="r"/>
                       <a:r>
-                        <a:rPr sz="1200">
+                        <a:rPr sz="1100">
                           <a:solidFill>
                             <a:srgbClr val="52514E"/>
                           </a:solidFill>
                           <a:latin typeface="Calibri"/>
                         </a:rPr>
-                        <a:t>0.332</a:t>
+                        <a:t>0.385</a:t>
                       </a:r>
                     </a:p>
                   </a:txBody>
@@ -13534,13 +14435,13 @@
                     <a:p>
                       <a:pPr algn="r"/>
                       <a:r>
-                        <a:rPr sz="1200">
+                        <a:rPr sz="1100">
                           <a:solidFill>
                             <a:srgbClr val="52514E"/>
                           </a:solidFill>
                           <a:latin typeface="Calibri"/>
                         </a:rPr>
-                        <a:t>29.6</a:t>
+                        <a:t>44.4</a:t>
                       </a:r>
                     </a:p>
                   </a:txBody>
@@ -13551,7 +14452,7 @@
                   </a:tcPr>
                 </a:tc>
               </a:tr>
-              <a:tr h="365760">
+              <a:tr h="329184">
                 <a:tc>
                   <a:txBody>
                     <a:bodyPr/>
@@ -13559,13 +14460,13 @@
                     <a:p>
                       <a:pPr algn="l"/>
                       <a:r>
-                        <a:rPr sz="1200">
+                        <a:rPr sz="1100">
                           <a:solidFill>
                             <a:srgbClr val="52514E"/>
                           </a:solidFill>
                           <a:latin typeface="Calibri"/>
                         </a:rPr>
-                        <a:t>One-Class SVM (+ our calibration &amp; event logic)</a:t>
+                        <a:t>Rolling z-score (+ our calibration &amp; event logic)</a:t>
                       </a:r>
                     </a:p>
                   </a:txBody>
@@ -13582,13 +14483,13 @@
                     <a:p>
                       <a:pPr algn="r"/>
                       <a:r>
-                        <a:rPr sz="1200">
+                        <a:rPr sz="1100">
                           <a:solidFill>
                             <a:srgbClr val="52514E"/>
                           </a:solidFill>
                           <a:latin typeface="Calibri"/>
                         </a:rPr>
-                        <a:t>0.307</a:t>
+                        <a:t>0.332</a:t>
                       </a:r>
                     </a:p>
                   </a:txBody>
@@ -13605,13 +14506,13 @@
                     <a:p>
                       <a:pPr algn="r"/>
                       <a:r>
-                        <a:rPr sz="1200">
+                        <a:rPr sz="1100">
                           <a:solidFill>
                             <a:srgbClr val="52514E"/>
                           </a:solidFill>
                           <a:latin typeface="Calibri"/>
                         </a:rPr>
-                        <a:t>0.307</a:t>
+                        <a:t>0.332</a:t>
                       </a:r>
                     </a:p>
                   </a:txBody>
@@ -13628,13 +14529,13 @@
                     <a:p>
                       <a:pPr algn="r"/>
                       <a:r>
-                        <a:rPr sz="1200">
+                        <a:rPr sz="1100">
                           <a:solidFill>
                             <a:srgbClr val="52514E"/>
                           </a:solidFill>
                           <a:latin typeface="Calibri"/>
                         </a:rPr>
-                        <a:t>0.266</a:t>
+                        <a:t>0.295</a:t>
                       </a:r>
                     </a:p>
                   </a:txBody>
@@ -13651,13 +14552,13 @@
                     <a:p>
                       <a:pPr algn="r"/>
                       <a:r>
-                        <a:rPr sz="1200">
+                        <a:rPr sz="1100">
                           <a:solidFill>
                             <a:srgbClr val="52514E"/>
                           </a:solidFill>
                           <a:latin typeface="Calibri"/>
                         </a:rPr>
-                        <a:t>0.362</a:t>
+                        <a:t>0.379</a:t>
                       </a:r>
                     </a:p>
                   </a:txBody>
@@ -13674,13 +14575,13 @@
                     <a:p>
                       <a:pPr algn="r"/>
                       <a:r>
-                        <a:rPr sz="1200">
+                        <a:rPr sz="1100">
                           <a:solidFill>
                             <a:srgbClr val="52514E"/>
                           </a:solidFill>
                           <a:latin typeface="Calibri"/>
                         </a:rPr>
-                        <a:t>116</a:t>
+                        <a:t>105</a:t>
                       </a:r>
                     </a:p>
                   </a:txBody>
@@ -13697,13 +14598,13 @@
                     <a:p>
                       <a:pPr algn="r"/>
                       <a:r>
-                        <a:rPr sz="1200">
+                        <a:rPr sz="1100">
                           <a:solidFill>
                             <a:srgbClr val="52514E"/>
                           </a:solidFill>
                           <a:latin typeface="Calibri"/>
                         </a:rPr>
-                        <a:t>0.307</a:t>
+                        <a:t>0.332</a:t>
                       </a:r>
                     </a:p>
                   </a:txBody>
@@ -13720,13 +14621,13 @@
                     <a:p>
                       <a:pPr algn="r"/>
                       <a:r>
-                        <a:rPr sz="1200">
+                        <a:rPr sz="1100">
                           <a:solidFill>
                             <a:srgbClr val="52514E"/>
                           </a:solidFill>
                           <a:latin typeface="Calibri"/>
                         </a:rPr>
-                        <a:t>27.8</a:t>
+                        <a:t>29.6</a:t>
                       </a:r>
                     </a:p>
                   </a:txBody>
@@ -13737,7 +14638,7 @@
                   </a:tcPr>
                 </a:tc>
               </a:tr>
-              <a:tr h="365760">
+              <a:tr h="329184">
                 <a:tc>
                   <a:txBody>
                     <a:bodyPr/>
@@ -13745,13 +14646,13 @@
                     <a:p>
                       <a:pPr algn="l"/>
                       <a:r>
-                        <a:rPr sz="1200">
+                        <a:rPr sz="1100">
                           <a:solidFill>
                             <a:srgbClr val="52514E"/>
                           </a:solidFill>
                           <a:latin typeface="Calibri"/>
                         </a:rPr>
-                        <a:t>Random (+ event logic)</a:t>
+                        <a:t>One-Class SVM (+ our calibration &amp; event logic)</a:t>
                       </a:r>
                     </a:p>
                   </a:txBody>
@@ -13768,13 +14669,13 @@
                     <a:p>
                       <a:pPr algn="r"/>
                       <a:r>
-                        <a:rPr sz="1200">
+                        <a:rPr sz="1100">
                           <a:solidFill>
                             <a:srgbClr val="52514E"/>
                           </a:solidFill>
                           <a:latin typeface="Calibri"/>
                         </a:rPr>
-                        <a:t>0.126</a:t>
+                        <a:t>0.307</a:t>
                       </a:r>
                     </a:p>
                   </a:txBody>
@@ -13791,13 +14692,13 @@
                     <a:p>
                       <a:pPr algn="r"/>
                       <a:r>
-                        <a:rPr sz="1200">
+                        <a:rPr sz="1100">
                           <a:solidFill>
                             <a:srgbClr val="52514E"/>
                           </a:solidFill>
                           <a:latin typeface="Calibri"/>
                         </a:rPr>
-                        <a:t>–</a:t>
+                        <a:t>0.307</a:t>
                       </a:r>
                     </a:p>
                   </a:txBody>
@@ -13814,13 +14715,13 @@
                     <a:p>
                       <a:pPr algn="r"/>
                       <a:r>
-                        <a:rPr sz="1200">
+                        <a:rPr sz="1100">
                           <a:solidFill>
                             <a:srgbClr val="52514E"/>
                           </a:solidFill>
                           <a:latin typeface="Calibri"/>
                         </a:rPr>
-                        <a:t>0.069</a:t>
+                        <a:t>0.266</a:t>
                       </a:r>
                     </a:p>
                   </a:txBody>
@@ -13837,13 +14738,13 @@
                     <a:p>
                       <a:pPr algn="r"/>
                       <a:r>
-                        <a:rPr sz="1200">
+                        <a:rPr sz="1100">
                           <a:solidFill>
                             <a:srgbClr val="52514E"/>
                           </a:solidFill>
                           <a:latin typeface="Calibri"/>
                         </a:rPr>
-                        <a:t>0.724</a:t>
+                        <a:t>0.362</a:t>
                       </a:r>
                     </a:p>
                   </a:txBody>
@@ -13860,13 +14761,13 @@
                     <a:p>
                       <a:pPr algn="r"/>
                       <a:r>
-                        <a:rPr sz="1200">
+                        <a:rPr sz="1100">
                           <a:solidFill>
                             <a:srgbClr val="52514E"/>
                           </a:solidFill>
                           <a:latin typeface="Calibri"/>
                         </a:rPr>
-                        <a:t>1137</a:t>
+                        <a:t>116</a:t>
                       </a:r>
                     </a:p>
                   </a:txBody>
@@ -13883,13 +14784,13 @@
                     <a:p>
                       <a:pPr algn="r"/>
                       <a:r>
-                        <a:rPr sz="1200">
+                        <a:rPr sz="1100">
                           <a:solidFill>
                             <a:srgbClr val="52514E"/>
                           </a:solidFill>
                           <a:latin typeface="Calibri"/>
                         </a:rPr>
-                        <a:t>0.178</a:t>
+                        <a:t>0.307</a:t>
                       </a:r>
                     </a:p>
                   </a:txBody>
@@ -13906,7 +14807,193 @@
                     <a:p>
                       <a:pPr algn="r"/>
                       <a:r>
-                        <a:rPr sz="1200">
+                        <a:rPr sz="1100">
+                          <a:solidFill>
+                            <a:srgbClr val="52514E"/>
+                          </a:solidFill>
+                          <a:latin typeface="Calibri"/>
+                        </a:rPr>
+                        <a:t>27.8</a:t>
+                      </a:r>
+                    </a:p>
+                  </a:txBody>
+                  <a:tcPr marL="73152" marR="73152" marT="27432" marB="27432" anchor="ctr">
+                    <a:solidFill>
+                      <a:srgbClr val="F7F7F5"/>
+                    </a:solidFill>
+                  </a:tcPr>
+                </a:tc>
+              </a:tr>
+              <a:tr h="329184">
+                <a:tc>
+                  <a:txBody>
+                    <a:bodyPr/>
+                    <a:lstStyle/>
+                    <a:p>
+                      <a:pPr algn="l"/>
+                      <a:r>
+                        <a:rPr sz="1100">
+                          <a:solidFill>
+                            <a:srgbClr val="52514E"/>
+                          </a:solidFill>
+                          <a:latin typeface="Calibri"/>
+                        </a:rPr>
+                        <a:t>Random (+ event logic)</a:t>
+                      </a:r>
+                    </a:p>
+                  </a:txBody>
+                  <a:tcPr marL="73152" marR="73152" marT="27432" marB="27432" anchor="ctr">
+                    <a:solidFill>
+                      <a:srgbClr val="FFFFFF"/>
+                    </a:solidFill>
+                  </a:tcPr>
+                </a:tc>
+                <a:tc>
+                  <a:txBody>
+                    <a:bodyPr/>
+                    <a:lstStyle/>
+                    <a:p>
+                      <a:pPr algn="r"/>
+                      <a:r>
+                        <a:rPr sz="1100">
+                          <a:solidFill>
+                            <a:srgbClr val="52514E"/>
+                          </a:solidFill>
+                          <a:latin typeface="Calibri"/>
+                        </a:rPr>
+                        <a:t>0.126</a:t>
+                      </a:r>
+                    </a:p>
+                  </a:txBody>
+                  <a:tcPr marL="73152" marR="73152" marT="27432" marB="27432" anchor="ctr">
+                    <a:solidFill>
+                      <a:srgbClr val="FFFFFF"/>
+                    </a:solidFill>
+                  </a:tcPr>
+                </a:tc>
+                <a:tc>
+                  <a:txBody>
+                    <a:bodyPr/>
+                    <a:lstStyle/>
+                    <a:p>
+                      <a:pPr algn="r"/>
+                      <a:r>
+                        <a:rPr sz="1100">
+                          <a:solidFill>
+                            <a:srgbClr val="52514E"/>
+                          </a:solidFill>
+                          <a:latin typeface="Calibri"/>
+                        </a:rPr>
+                        <a:t>–</a:t>
+                      </a:r>
+                    </a:p>
+                  </a:txBody>
+                  <a:tcPr marL="73152" marR="73152" marT="27432" marB="27432" anchor="ctr">
+                    <a:solidFill>
+                      <a:srgbClr val="FFFFFF"/>
+                    </a:solidFill>
+                  </a:tcPr>
+                </a:tc>
+                <a:tc>
+                  <a:txBody>
+                    <a:bodyPr/>
+                    <a:lstStyle/>
+                    <a:p>
+                      <a:pPr algn="r"/>
+                      <a:r>
+                        <a:rPr sz="1100">
+                          <a:solidFill>
+                            <a:srgbClr val="52514E"/>
+                          </a:solidFill>
+                          <a:latin typeface="Calibri"/>
+                        </a:rPr>
+                        <a:t>0.069</a:t>
+                      </a:r>
+                    </a:p>
+                  </a:txBody>
+                  <a:tcPr marL="73152" marR="73152" marT="27432" marB="27432" anchor="ctr">
+                    <a:solidFill>
+                      <a:srgbClr val="FFFFFF"/>
+                    </a:solidFill>
+                  </a:tcPr>
+                </a:tc>
+                <a:tc>
+                  <a:txBody>
+                    <a:bodyPr/>
+                    <a:lstStyle/>
+                    <a:p>
+                      <a:pPr algn="r"/>
+                      <a:r>
+                        <a:rPr sz="1100">
+                          <a:solidFill>
+                            <a:srgbClr val="52514E"/>
+                          </a:solidFill>
+                          <a:latin typeface="Calibri"/>
+                        </a:rPr>
+                        <a:t>0.724</a:t>
+                      </a:r>
+                    </a:p>
+                  </a:txBody>
+                  <a:tcPr marL="73152" marR="73152" marT="27432" marB="27432" anchor="ctr">
+                    <a:solidFill>
+                      <a:srgbClr val="FFFFFF"/>
+                    </a:solidFill>
+                  </a:tcPr>
+                </a:tc>
+                <a:tc>
+                  <a:txBody>
+                    <a:bodyPr/>
+                    <a:lstStyle/>
+                    <a:p>
+                      <a:pPr algn="r"/>
+                      <a:r>
+                        <a:rPr sz="1100">
+                          <a:solidFill>
+                            <a:srgbClr val="52514E"/>
+                          </a:solidFill>
+                          <a:latin typeface="Calibri"/>
+                        </a:rPr>
+                        <a:t>1137</a:t>
+                      </a:r>
+                    </a:p>
+                  </a:txBody>
+                  <a:tcPr marL="73152" marR="73152" marT="27432" marB="27432" anchor="ctr">
+                    <a:solidFill>
+                      <a:srgbClr val="FFFFFF"/>
+                    </a:solidFill>
+                  </a:tcPr>
+                </a:tc>
+                <a:tc>
+                  <a:txBody>
+                    <a:bodyPr/>
+                    <a:lstStyle/>
+                    <a:p>
+                      <a:pPr algn="r"/>
+                      <a:r>
+                        <a:rPr sz="1100">
+                          <a:solidFill>
+                            <a:srgbClr val="52514E"/>
+                          </a:solidFill>
+                          <a:latin typeface="Calibri"/>
+                        </a:rPr>
+                        <a:t>0.178</a:t>
+                      </a:r>
+                    </a:p>
+                  </a:txBody>
+                  <a:tcPr marL="73152" marR="73152" marT="27432" marB="27432" anchor="ctr">
+                    <a:solidFill>
+                      <a:srgbClr val="FFFFFF"/>
+                    </a:solidFill>
+                  </a:tcPr>
+                </a:tc>
+                <a:tc>
+                  <a:txBody>
+                    <a:bodyPr/>
+                    <a:lstStyle/>
+                    <a:p>
+                      <a:pPr algn="r"/>
+                      <a:r>
+                        <a:rPr sz="1100">
                           <a:solidFill>
                             <a:srgbClr val="52514E"/>
                           </a:solidFill>
@@ -13918,7 +15005,7 @@
                   </a:txBody>
                   <a:tcPr marL="73152" marR="73152" marT="27432" marB="27432" anchor="ctr">
                     <a:solidFill>
-                      <a:srgbClr val="F7F7F5"/>
+                      <a:srgbClr val="FFFFFF"/>
                     </a:solidFill>
                   </a:tcPr>
                 </a:tc>
@@ -13935,7 +15022,7 @@
         </p:nvSpPr>
         <p:spPr>
           <a:xfrm>
-            <a:off x="548640" y="5349240"/>
+            <a:off x="548640" y="5422392"/>
             <a:ext cx="11064240" cy="822960"/>
           </a:xfrm>
           <a:prstGeom prst="rect">
@@ -14229,7 +15316,7 @@
                 </a:solidFill>
                 <a:latin typeface="Calibri"/>
               </a:rPr>
-              <a:t>  ·  ec2_cpu_utilization_825cc2.csv  ·  2014-04-15 16:59:00</a:t>
+              <a:t>  ·  machine_temperature_system_failure.csv  ·  2014-02-09 12:10:00</a:t>
             </a:r>
           </a:p>
         </p:txBody>
@@ -14264,7 +15351,7 @@
                 </a:solidFill>
                 <a:latin typeface="Calibri"/>
               </a:rPr>
-              <a:t>Value 54.78 is 9.8x the normal spread below the expected 93.78. Also: Sustained downward shift: recent mean 85.91 vs baseline 93.32 for 38 points.</a:t>
+              <a:t>Value 69.6 is 11.6x the normal spread above the expected 32.08. Also: Pattern break: only 74% of the last 32 values' shape is explained by the 3 usual patterns of the learning period.</a:t>
             </a:r>
           </a:p>
         </p:txBody>
@@ -14354,7 +15441,7 @@
                 </a:solidFill>
                 <a:latin typeface="Calibri"/>
               </a:rPr>
-              <a:t>  ·  Twitter_volume_FB.csv  ·  2015-04-03 17:47:53</a:t>
+              <a:t>  ·  art_daily_flatmiddle.csv  ·  2014-04-11 00:10:00</a:t>
             </a:r>
           </a:p>
         </p:txBody>
@@ -14389,7 +15476,7 @@
                 </a:solidFill>
                 <a:latin typeface="Calibri"/>
               </a:rPr>
-              <a:t>Value 1258 is 58.2x the normal spread above the expected 11. Also: Sustained upward shift: recent mean 107.1 vs baseline 16.83 for 2 points.</a:t>
+              <a:t>Sustained upward shift: level after removing the daily/weekly pattern -11.61 vs baseline -19.19 for 3 points. Also: Value 40 is 10.3x the normal spread above the expected -8.709 (daily pattern, 00:00).</a:t>
             </a:r>
           </a:p>
         </p:txBody>
@@ -14479,7 +15566,7 @@
                 </a:solidFill>
                 <a:latin typeface="Calibri"/>
               </a:rPr>
-              <a:t>  ·  art_noisy.csv  ·  2014-04-04 22:10:00</a:t>
+              <a:t>  ·  ec2_network_in_257a54.csv  ·  2014-04-22 16:14:00</a:t>
             </a:r>
           </a:p>
         </p:txBody>
@@ -14514,7 +15601,7 @@
                 </a:solidFill>
                 <a:latin typeface="Calibri"/>
               </a:rPr>
-              <a:t>Variance change: values became much more spread out around the baseline 13.55 over 41 points.</a:t>
+              <a:t>Sustained upward shift: level after removing the daily/weekly pattern -3.35e+06 vs baseline -3.399e+06 for 3 points.</a:t>
             </a:r>
           </a:p>
           <a:p>
@@ -14526,7 +15613,7 @@
                 </a:solidFill>
                 <a:latin typeface="Calibri"/>
               </a:rPr>
-              <a:t>This file is pure noise with no anomaly (NAB artificialNoAnomaly): the variance CUSUM crossed θ on a chance run of wide swings. False alerts on the 5 anomaly-free files: 1.</a:t>
+              <a:t>Triggered outside every labelled window (see figures/examples_fp.png for context).</a:t>
             </a:r>
           </a:p>
         </p:txBody>

</xml_diff>